<commit_message>
Regenerate every committed document
Six narrated reports across three case studies, each with every section
narrated and verified and none rejected, plus the twelve example readouts.

What changed in them: both standing assumptions now appear in three
sections rather than eight; the estimates appear in the results section
and, for the one the answer turns on, in the abstract and conclusions; the
prose names its own figures and tables; the identification graph is stated
as an edge list, tabled as arrows and drawn; the estimating equations are
written out; and the provenance appendix has its two tables back.

Co-Authored-By: Claude Opus 5 (1M context) <noreply@anthropic.com>
Claude-Session: https://claude.ai/code/session_01RWKKr8isMw6hygFZdyGZUF
</commit_message>
<xml_diff>
--- a/packages/axiom-dossier/examples/out/hyper3-apa.pptx
+++ b/packages/axiom-dossier/examples/out/hyper3-apa.pptx
@@ -22,6 +22,9 @@
     <p:sldId id="270" r:id="rId21"/>
     <p:sldId id="271" r:id="rId22"/>
     <p:sldId id="272" r:id="rId23"/>
+    <p:sldId id="273" r:id="rId24"/>
+    <p:sldId id="274" r:id="rId25"/>
+    <p:sldId id="275" r:id="rId26"/>
   </p:sldIdLst>
   <p:sldSz cx="12192000" cy="6858000" type="screen4x3"/>
   <p:notesSz cx="6858000" cy="9144000"/>
@@ -3193,7 +3196,7 @@
                   <a:srgbClr val="000000"/>
                 </a:solidFill>
               </a:rPr>
-              <a:t>Discussion</a:t>
+              <a:t>Model checking</a:t>
             </a:r>
           </a:p>
         </p:txBody>
@@ -3207,6 +3210,178 @@
         <p:spPr>
           <a:xfrm>
             <a:off x="914400" y="965200"/>
+            <a:ext cx="2489200" cy="889000"/>
+          </a:xfrm>
+          <a:prstGeom prst="rect">
+            <a:avLst/>
+          </a:prstGeom>
+          <a:noFill/>
+        </p:spPr>
+        <p:txBody>
+          <a:bodyPr wrap="square">
+            <a:spAutoFit/>
+          </a:bodyPr>
+          <a:lstStyle/>
+          <a:p>
+            <a:r>
+              <a:rPr sz="1019" b="0">
+                <a:solidFill>
+                  <a:srgbClr val="000000"/>
+                </a:solidFill>
+              </a:rPr>
+              <a:t>UNITS STILL ON STUDY AT THE FINAL WEEK</a:t>
+            </a:r>
+          </a:p>
+          <a:p>
+            <a:r>
+              <a:rPr sz="960" b="1">
+                <a:solidFill>
+                  <a:srgbClr val="000000"/>
+                </a:solidFill>
+              </a:rPr>
+              <a:t>0.797</a:t>
+            </a:r>
+          </a:p>
+        </p:txBody>
+      </p:sp>
+      <p:sp>
+        <p:nvSpPr>
+          <p:cNvPr id="4" name="TextBox 3"/>
+          <p:cNvSpPr txBox="1"/>
+          <p:nvPr/>
+        </p:nvSpPr>
+        <p:spPr>
+          <a:xfrm>
+            <a:off x="3505200" y="965200"/>
+            <a:ext cx="2489200" cy="889000"/>
+          </a:xfrm>
+          <a:prstGeom prst="rect">
+            <a:avLst/>
+          </a:prstGeom>
+          <a:noFill/>
+        </p:spPr>
+        <p:txBody>
+          <a:bodyPr wrap="square">
+            <a:spAutoFit/>
+          </a:bodyPr>
+          <a:lstStyle/>
+          <a:p>
+            <a:r>
+              <a:rPr sz="1019" b="0">
+                <a:solidFill>
+                  <a:srgbClr val="000000"/>
+                </a:solidFill>
+              </a:rPr>
+              <a:t>UNITS CONTRIBUTING TO THE PRIMARY ENDPOINT</a:t>
+            </a:r>
+          </a:p>
+          <a:p>
+            <a:r>
+              <a:rPr sz="960" b="1">
+                <a:solidFill>
+                  <a:srgbClr val="000000"/>
+                </a:solidFill>
+              </a:rPr>
+              <a:t>372</a:t>
+            </a:r>
+          </a:p>
+        </p:txBody>
+      </p:sp>
+      <p:sp>
+        <p:nvSpPr>
+          <p:cNvPr id="5" name="TextBox 4"/>
+          <p:cNvSpPr txBox="1"/>
+          <p:nvPr/>
+        </p:nvSpPr>
+        <p:spPr>
+          <a:xfrm>
+            <a:off x="6096000" y="965200"/>
+            <a:ext cx="2489200" cy="889000"/>
+          </a:xfrm>
+          <a:prstGeom prst="rect">
+            <a:avLst/>
+          </a:prstGeom>
+          <a:noFill/>
+        </p:spPr>
+        <p:txBody>
+          <a:bodyPr wrap="square">
+            <a:spAutoFit/>
+          </a:bodyPr>
+          <a:lstStyle/>
+          <a:p>
+            <a:r>
+              <a:rPr sz="1019" b="0">
+                <a:solidFill>
+                  <a:srgbClr val="000000"/>
+                </a:solidFill>
+              </a:rPr>
+              <a:t>UNITS RANDOMIZED IN BAND AGE 25 35</a:t>
+            </a:r>
+          </a:p>
+          <a:p>
+            <a:r>
+              <a:rPr sz="960" b="1">
+                <a:solidFill>
+                  <a:srgbClr val="000000"/>
+                </a:solidFill>
+              </a:rPr>
+              <a:t>100</a:t>
+            </a:r>
+          </a:p>
+        </p:txBody>
+      </p:sp>
+      <p:sp>
+        <p:nvSpPr>
+          <p:cNvPr id="6" name="TextBox 5"/>
+          <p:cNvSpPr txBox="1"/>
+          <p:nvPr/>
+        </p:nvSpPr>
+        <p:spPr>
+          <a:xfrm>
+            <a:off x="8686800" y="965200"/>
+            <a:ext cx="2489200" cy="889000"/>
+          </a:xfrm>
+          <a:prstGeom prst="rect">
+            <a:avLst/>
+          </a:prstGeom>
+          <a:noFill/>
+        </p:spPr>
+        <p:txBody>
+          <a:bodyPr wrap="square">
+            <a:spAutoFit/>
+          </a:bodyPr>
+          <a:lstStyle/>
+          <a:p>
+            <a:r>
+              <a:rPr sz="1019" b="0">
+                <a:solidFill>
+                  <a:srgbClr val="000000"/>
+                </a:solidFill>
+              </a:rPr>
+              <a:t>UNITS RANDOMIZED IN BAND AGE 36 50</a:t>
+            </a:r>
+          </a:p>
+          <a:p>
+            <a:r>
+              <a:rPr sz="960" b="1">
+                <a:solidFill>
+                  <a:srgbClr val="000000"/>
+                </a:solidFill>
+              </a:rPr>
+              <a:t>160</a:t>
+            </a:r>
+          </a:p>
+        </p:txBody>
+      </p:sp>
+      <p:sp>
+        <p:nvSpPr>
+          <p:cNvPr id="7" name="TextBox 6"/>
+          <p:cNvSpPr txBox="1"/>
+          <p:nvPr/>
+        </p:nvSpPr>
+        <p:spPr>
+          <a:xfrm>
+            <a:off x="914400" y="2006600"/>
             <a:ext cx="10363200" cy="508000"/>
           </a:xfrm>
           <a:prstGeom prst="rect">
@@ -3226,7 +3401,7 @@
                   <a:srgbClr val="000000"/>
                 </a:solidFill>
               </a:rPr>
-              <a:t>The target effect is identified via the backdoor route, which allows the estimates to be interpreted as effects of treatment rather than associations, subject to the trial assumptions. For the pooled comparison of 40 mg versus control, the effect is -1.53 mmHg (90% WALD -2.97 to -0.10 mmHg), which lies entirely below the decision threshold on the favorable side. This pooled figure averages an age stratum where the dose helps with one where it harms. For the pooled comparison of 20 mg versus control, the effect is -4.80 mmHg (90% WALD -6.17 to -3.44 mmHg), falling entirely on the favorable side of the threshold. Similarly, the pooled contrast for 10 mg versus control is -5.27 mmHg (90% WALD -6.63 to -3.91 mmHg), which also lies entirely below the decision threshold. Stratum-level estimates clarify the performance of the highest dose across age groups. For 40 mg versus control among participants aged 51 and older, the effect is 6.20 mmHg (90% WALD 3.98 to 8.42 mmHg), falling entirely on the unfavorable side of the threshold. This subgroup contrast reflects the harm that the safety boundary was designed to monitor, which the pooled estimate conceals. For 40 mg versus control among participants aged 25 to 35, the effect is -5.26 mmHg (90% WALD -8.17 to -2.36 mmHg), lying entirely below the decision threshold on the favorable side. These findings remain conditional on the unresolved assumptions that dropout is ignorable given baseline and that the pooled contrast answers the question.</a:t>
+              <a:t>Diagnostic checks assess the behavior of the sample and model fit rather than the estimated effect. A check of this kind can lower confidence in an estimate and can never establish one. The recorded diagnostics for HYPER-3 are reported in Table 3. The fraction of units still on study at the final week was 0.797. The study includes 372 units contributing to the primary endpoint. Across age categories, there were 100 units randomized in band age 25 35. There were 160 units randomized in band age 36 50. The study recorded 140 units randomized in band age 51 plus. These metrics examine observed retention and sample partitions, whereas the broader assumptions specified in the methods remain unexamined by these diagnostic counts.</a:t>
             </a:r>
           </a:p>
         </p:txBody>
@@ -3277,7 +3452,7 @@
                   <a:srgbClr val="000000"/>
                 </a:solidFill>
               </a:rPr>
-              <a:t>Conclusions</a:t>
+              <a:t>Model checking (cont.)</a:t>
             </a:r>
           </a:p>
         </p:txBody>
@@ -3291,7 +3466,7 @@
         <p:spPr>
           <a:xfrm>
             <a:off x="914400" y="965200"/>
-            <a:ext cx="10363200" cy="508000"/>
+            <a:ext cx="10261600" cy="889000"/>
           </a:xfrm>
           <a:prstGeom prst="rect">
             <a:avLst/>
@@ -3305,12 +3480,22 @@
           <a:lstStyle/>
           <a:p>
             <a:r>
-              <a:rPr sz="1200" b="0">
+              <a:rPr sz="1019" b="0">
                 <a:solidFill>
                   <a:srgbClr val="000000"/>
                 </a:solidFill>
               </a:rPr>
-              <a:t>Determining which daily dose should advance to phase III and whether any dose produces harm cannot be answered with a single summary metric, conditional on the unresolved assumptions that dropout is ignorable given baseline and that the pooled contrast answers the question. For 40 mg vs control in the age 51+ band, the estimate is 6.20 mmHg (90% WALD 3.98 to 8.42 mmHg), which sits on the unfavourable side of the threshold. Four other findings sit on the favourable side of the threshold. The pooled estimate for 40 mg vs control is -1.53 mmHg (90% WALD -2.97 to -0.10 mmHg). For 40 mg vs control in the age 25-35 band, the estimate is -5.26 mmHg (90% WALD -8.17 to -2.36 mmHg). For 20 mg vs control, the pooled estimate is -4.80 mmHg (90% WALD -6.17 to -3.44 mmHg). For 10 mg vs control, the pooled estimate is -5.27 mmHg (90% WALD -6.63 to -3.91 mmHg). Any single summary estimate averages harm with benefit across strata. When an overall average is quoted, it conceals stratum-specific harm behind overall benefit. Consequently, the disaggregated findings are the result, and the pooled figure is not a substitute for them. The target effects are identified via the backdoor route. All findings hold under the unresolved assumptions that dropout is ignorable given baseline and that the pooled contrast answers the question.</a:t>
+              <a:t>UNITS RANDOMIZED IN BAND AGE 51 PLUS</a:t>
+            </a:r>
+          </a:p>
+          <a:p>
+            <a:r>
+              <a:rPr sz="960" b="1">
+                <a:solidFill>
+                  <a:srgbClr val="000000"/>
+                </a:solidFill>
+              </a:rPr>
+              <a:t>140</a:t>
             </a:r>
           </a:p>
         </p:txBody>
@@ -3361,7 +3546,7 @@
                   <a:srgbClr val="000000"/>
                 </a:solidFill>
               </a:rPr>
-              <a:t>Limitations</a:t>
+              <a:t>Discussion</a:t>
             </a:r>
           </a:p>
         </p:txBody>
@@ -3394,7 +3579,7 @@
                   <a:srgbClr val="000000"/>
                 </a:solidFill>
               </a:rPr>
-              <a:t>Two unresolved assumptions underlie the analysis. The first assumption is that dropout is ignorable given baseline. Under this assumption, units who left the study differ from those who stayed only through what was measured before randomization. This licenses estimating treatment contrasts without modeling unobserved mechanisms of attrition. This condition is assumed and has not been checked. It would be challenged by a tipping-point analysis over plausible departures from ignorability. The second assumption is that the pooled contrast answers the question. Under this assumption, a single number over all age bands describes the effect the decision is about. This licenses evaluating outcomes using aggregate estimates across all strata. This assumption is known to fail. It is challenged by heterogeneity across the pre-specified strata.</a:t>
+              <a:t>For 40 mg vs control in the age 51+ group, the estimate settled above the threshold on the unfavourable side, marking the primary divergence in these data. This result contrasts with the younger cohort, where 40 mg vs control for ages 25-35 settled below the threshold on the favourable side. The pooled comparisons mask this age variation: 40 mg vs control, 20 mg vs control, and 10 mg vs control each settled below the threshold on the favourable side when pooled. That divergence at 40 mg indicates that the favourable pooled finding does not extend to older participants. Because the analysis relies on the backdoor identification route established in the methods, these findings license reading the estimates as effects of the treatments rather than simple associations. They do not license inferences beyond what that identification structure supports. All interpretations remain conditional on 2 unresolved assumptions. The limitations section details what each of those assumptions claims. What was found is that while younger cohorts and lower pooled doses yield favourable outcomes, the highest dose produces an unfavourable outcome in older participants, raising the question of how phase III dose selection should manage age-specific risks.</a:t>
             </a:r>
           </a:p>
         </p:txBody>
@@ -3408,6 +3593,174 @@
 </file>
 
 <file path=ppt/slides/slide13.xml><?xml version="1.0" encoding="utf-8"?>
+<p:sld xmlns:a="http://schemas.openxmlformats.org/drawingml/2006/main" xmlns:p="http://schemas.openxmlformats.org/presentationml/2006/main" xmlns:r="http://schemas.openxmlformats.org/officeDocument/2006/relationships">
+  <p:cSld>
+    <p:spTree>
+      <p:nvGrpSpPr>
+        <p:cNvPr id="1" name=""/>
+        <p:cNvGrpSpPr/>
+        <p:nvPr/>
+      </p:nvGrpSpPr>
+      <p:grpSpPr/>
+      <p:sp>
+        <p:nvSpPr>
+          <p:cNvPr id="2" name="TextBox 1"/>
+          <p:cNvSpPr txBox="1"/>
+          <p:nvPr/>
+        </p:nvSpPr>
+        <p:spPr>
+          <a:xfrm>
+            <a:off x="914400" y="457200"/>
+            <a:ext cx="10363200" cy="431800"/>
+          </a:xfrm>
+          <a:prstGeom prst="rect">
+            <a:avLst/>
+          </a:prstGeom>
+          <a:noFill/>
+        </p:spPr>
+        <p:txBody>
+          <a:bodyPr wrap="square">
+            <a:spAutoFit/>
+          </a:bodyPr>
+          <a:lstStyle/>
+          <a:p>
+            <a:r>
+              <a:rPr sz="1200" b="1">
+                <a:solidFill>
+                  <a:srgbClr val="000000"/>
+                </a:solidFill>
+              </a:rPr>
+              <a:t>Conclusions</a:t>
+            </a:r>
+          </a:p>
+        </p:txBody>
+      </p:sp>
+      <p:sp>
+        <p:nvSpPr>
+          <p:cNvPr id="3" name="TextBox 2"/>
+          <p:cNvSpPr txBox="1"/>
+          <p:nvPr/>
+        </p:nvSpPr>
+        <p:spPr>
+          <a:xfrm>
+            <a:off x="914400" y="965200"/>
+            <a:ext cx="10363200" cy="508000"/>
+          </a:xfrm>
+          <a:prstGeom prst="rect">
+            <a:avLst/>
+          </a:prstGeom>
+          <a:noFill/>
+        </p:spPr>
+        <p:txBody>
+          <a:bodyPr wrap="square">
+            <a:spAutoFit/>
+          </a:bodyPr>
+          <a:lstStyle/>
+          <a:p>
+            <a:r>
+              <a:rPr sz="1200" b="0">
+                <a:solidFill>
+                  <a:srgbClr val="000000"/>
+                </a:solidFill>
+              </a:rPr>
+              <a:t>No single daily dose can be recommended for phase III across all groups, as the 40 mg dose harms older participants. For participants aged 51 and older, the 40 mg versus control contrast settled on the unfavourable side of the decision threshold at 6.20 mmHg (90% WALD 3.98 to 8.42 mmHg). Conversely, the pooled comparisons for 10 mg, 20 mg, and 40 mg versus control each settled on the favourable side of the threshold. The subgroup contrast for 40 mg versus control among participants aged 25 to 35 likewise settled on the favourable side. Because the subgroup results diverge across age brackets, a pooled figure averages benefit with harm. The effect is identified following the structure established in the methods. This answer is conditional on 2 unresolved assumptions stated in the limitations section. Specifically, the conclusions hold provided that dropout is ignorable given baseline and that the pooled contrast answers the question.</a:t>
+            </a:r>
+          </a:p>
+        </p:txBody>
+      </p:sp>
+    </p:spTree>
+  </p:cSld>
+  <p:clrMapOvr>
+    <a:masterClrMapping/>
+  </p:clrMapOvr>
+</p:sld>
+</file>
+
+<file path=ppt/slides/slide14.xml><?xml version="1.0" encoding="utf-8"?>
+<p:sld xmlns:a="http://schemas.openxmlformats.org/drawingml/2006/main" xmlns:p="http://schemas.openxmlformats.org/presentationml/2006/main" xmlns:r="http://schemas.openxmlformats.org/officeDocument/2006/relationships">
+  <p:cSld>
+    <p:spTree>
+      <p:nvGrpSpPr>
+        <p:cNvPr id="1" name=""/>
+        <p:cNvGrpSpPr/>
+        <p:nvPr/>
+      </p:nvGrpSpPr>
+      <p:grpSpPr/>
+      <p:sp>
+        <p:nvSpPr>
+          <p:cNvPr id="2" name="TextBox 1"/>
+          <p:cNvSpPr txBox="1"/>
+          <p:nvPr/>
+        </p:nvSpPr>
+        <p:spPr>
+          <a:xfrm>
+            <a:off x="914400" y="457200"/>
+            <a:ext cx="10363200" cy="431800"/>
+          </a:xfrm>
+          <a:prstGeom prst="rect">
+            <a:avLst/>
+          </a:prstGeom>
+          <a:noFill/>
+        </p:spPr>
+        <p:txBody>
+          <a:bodyPr wrap="square">
+            <a:spAutoFit/>
+          </a:bodyPr>
+          <a:lstStyle/>
+          <a:p>
+            <a:r>
+              <a:rPr sz="1200" b="1">
+                <a:solidFill>
+                  <a:srgbClr val="000000"/>
+                </a:solidFill>
+              </a:rPr>
+              <a:t>Limitations</a:t>
+            </a:r>
+          </a:p>
+        </p:txBody>
+      </p:sp>
+      <p:sp>
+        <p:nvSpPr>
+          <p:cNvPr id="3" name="TextBox 2"/>
+          <p:cNvSpPr txBox="1"/>
+          <p:nvPr/>
+        </p:nvSpPr>
+        <p:spPr>
+          <a:xfrm>
+            <a:off x="914400" y="965200"/>
+            <a:ext cx="10363200" cy="508000"/>
+          </a:xfrm>
+          <a:prstGeom prst="rect">
+            <a:avLst/>
+          </a:prstGeom>
+          <a:noFill/>
+        </p:spPr>
+        <p:txBody>
+          <a:bodyPr wrap="square">
+            <a:spAutoFit/>
+          </a:bodyPr>
+          <a:lstStyle/>
+          <a:p>
+            <a:r>
+              <a:rPr sz="1200" b="0">
+                <a:solidFill>
+                  <a:srgbClr val="000000"/>
+                </a:solidFill>
+              </a:rPr>
+              <a:t>The analysis relies on standing assumptions, beginning with one that is violated. The assumption that the pooled contrast answers the question claims that a single number over all age bands describes the effect the decision is about. This assumption licenses using an aggregate contrast to address the decision problem set out in the introduction. That claim is challenged by heterogeneity across the pre-specified strata. In addition, the assumption that dropout is ignorable given baseline remains unverified. This assumption claims that units who left the study differ from those who stayed only through what was measured before randomization. It licenses the identified effect despite subject attrition under the design described in the methods. This condition is challenged by a tipping-point analysis over plausible departures from ignorability.</a:t>
+            </a:r>
+          </a:p>
+        </p:txBody>
+      </p:sp>
+    </p:spTree>
+  </p:cSld>
+  <p:clrMapOvr>
+    <a:masterClrMapping/>
+  </p:clrMapOvr>
+</p:sld>
+</file>
+
+<file path=ppt/slides/slide15.xml><?xml version="1.0" encoding="utf-8"?>
 <p:sld xmlns:a="http://schemas.openxmlformats.org/drawingml/2006/main" xmlns:p="http://schemas.openxmlformats.org/presentationml/2006/main" xmlns:r="http://schemas.openxmlformats.org/officeDocument/2006/relationships">
   <p:cSld>
     <p:spTree>
@@ -4303,7 +4656,7 @@
                 <a:gridCol w="5181600"/>
                 <a:gridCol w="5181600"/>
               </a:tblGrid>
-              <a:tr h="76200">
+              <a:tr h="71120">
                 <a:tc>
                   <a:txBody>
                     <a:bodyPr/>
@@ -4339,7 +4692,7 @@
                   <a:tcPr/>
                 </a:tc>
               </a:tr>
-              <a:tr h="76200">
+              <a:tr h="71120">
                 <a:tc>
                   <a:txBody>
                     <a:bodyPr/>
@@ -4375,7 +4728,7 @@
                   <a:tcPr/>
                 </a:tc>
               </a:tr>
-              <a:tr h="76200">
+              <a:tr h="71120">
                 <a:tc>
                   <a:txBody>
                     <a:bodyPr/>
@@ -4411,7 +4764,7 @@
                   <a:tcPr/>
                 </a:tc>
               </a:tr>
-              <a:tr h="76200">
+              <a:tr h="71120">
                 <a:tc>
                   <a:txBody>
                     <a:bodyPr/>
@@ -4447,7 +4800,7 @@
                   <a:tcPr/>
                 </a:tc>
               </a:tr>
-              <a:tr h="76200">
+              <a:tr h="71120">
                 <a:tc>
                   <a:txBody>
                     <a:bodyPr/>
@@ -4483,7 +4836,7 @@
                   <a:tcPr/>
                 </a:tc>
               </a:tr>
-              <a:tr h="76200">
+              <a:tr h="71120">
                 <a:tc>
                   <a:txBody>
                     <a:bodyPr/>
@@ -4512,14 +4865,14 @@
                             <a:srgbClr val="000000"/>
                           </a:solidFill>
                         </a:rPr>
-                        <a:t>962d1a7970f3f2dfdc0297e7d9d6d16dd568a5441fc1cfaa7c44837d40f9c2e5</a:t>
+                        <a:t>f6c953a837c79459cb14b031868abf7f0b1adb6e235b32abca19246ffd9d5ecc</a:t>
                       </a:r>
                     </a:p>
                   </a:txBody>
                   <a:tcPr/>
                 </a:tc>
               </a:tr>
-              <a:tr h="76200">
+              <a:tr h="71120">
                 <a:tc>
                   <a:txBody>
                     <a:bodyPr/>
@@ -4555,7 +4908,43 @@
                   <a:tcPr/>
                 </a:tc>
               </a:tr>
-              <a:tr h="76200">
+              <a:tr h="71120">
+                <a:tc>
+                  <a:txBody>
+                    <a:bodyPr/>
+                    <a:lstStyle/>
+                    <a:p>
+                      <a:r>
+                        <a:rPr sz="1019" b="0">
+                          <a:solidFill>
+                            <a:srgbClr val="000000"/>
+                          </a:solidFill>
+                        </a:rPr>
+                        <a:t>narration: title_page</a:t>
+                      </a:r>
+                    </a:p>
+                  </a:txBody>
+                  <a:tcPr/>
+                </a:tc>
+                <a:tc>
+                  <a:txBody>
+                    <a:bodyPr/>
+                    <a:lstStyle/>
+                    <a:p>
+                      <a:r>
+                        <a:rPr sz="1019" b="0">
+                          <a:solidFill>
+                            <a:srgbClr val="000000"/>
+                          </a:solidFill>
+                        </a:rPr>
+                        <a:t>gemini-3.7-flash — verified</a:t>
+                      </a:r>
+                    </a:p>
+                  </a:txBody>
+                  <a:tcPr/>
+                </a:tc>
+              </a:tr>
+              <a:tr h="71120">
                 <a:tc>
                   <a:txBody>
                     <a:bodyPr/>
@@ -4591,7 +4980,7 @@
                   <a:tcPr/>
                 </a:tc>
               </a:tr>
-              <a:tr h="76200">
+              <a:tr h="71120">
                 <a:tc>
                   <a:txBody>
                     <a:bodyPr/>
@@ -4627,7 +5016,7 @@
                   <a:tcPr/>
                 </a:tc>
               </a:tr>
-              <a:tr h="76200">
+              <a:tr h="71120">
                 <a:tc>
                   <a:txBody>
                     <a:bodyPr/>
@@ -4663,7 +5052,7 @@
                   <a:tcPr/>
                 </a:tc>
               </a:tr>
-              <a:tr h="76200">
+              <a:tr h="71120">
                 <a:tc>
                   <a:txBody>
                     <a:bodyPr/>
@@ -4699,7 +5088,7 @@
                   <a:tcPr/>
                 </a:tc>
               </a:tr>
-              <a:tr h="76200">
+              <a:tr h="71120">
                 <a:tc>
                   <a:txBody>
                     <a:bodyPr/>
@@ -4735,7 +5124,7 @@
                   <a:tcPr/>
                 </a:tc>
               </a:tr>
-              <a:tr h="76200">
+              <a:tr h="71120">
                 <a:tc>
                   <a:txBody>
                     <a:bodyPr/>
@@ -4771,7 +5160,7 @@
                   <a:tcPr/>
                 </a:tc>
               </a:tr>
-              <a:tr h="76200">
+              <a:tr h="71120">
                 <a:tc>
                   <a:txBody>
                     <a:bodyPr/>
@@ -4819,7 +5208,7 @@
 </p:sld>
 </file>
 
-<file path=ppt/slides/slide14.xml><?xml version="1.0" encoding="utf-8"?>
+<file path=ppt/slides/slide16.xml><?xml version="1.0" encoding="utf-8"?>
 <p:sld xmlns:a="http://schemas.openxmlformats.org/drawingml/2006/main" xmlns:p="http://schemas.openxmlformats.org/presentationml/2006/main" xmlns:r="http://schemas.openxmlformats.org/officeDocument/2006/relationships">
   <p:cSld>
     <p:spTree>
@@ -4918,7 +5307,7 @@
                 <a:gridCol w="3454400"/>
                 <a:gridCol w="3454400"/>
               </a:tblGrid>
-              <a:tr h="262466">
+              <a:tr h="236220">
                 <a:tc>
                   <a:txBody>
                     <a:bodyPr/>
@@ -4971,7 +5360,7 @@
                   <a:tcPr/>
                 </a:tc>
               </a:tr>
-              <a:tr h="262466">
+              <a:tr h="236220">
                 <a:tc>
                   <a:txBody>
                     <a:bodyPr/>
@@ -5000,6 +5389,112 @@
                             <a:srgbClr val="000000"/>
                           </a:solidFill>
                         </a:rPr>
+                        <a:t>graph</a:t>
+                      </a:r>
+                    </a:p>
+                  </a:txBody>
+                  <a:tcPr/>
+                </a:tc>
+                <a:tc>
+                  <a:txBody>
+                    <a:bodyPr/>
+                    <a:lstStyle/>
+                    <a:p>
+                      <a:r>
+                        <a:rPr sz="1019" b="0">
+                          <a:solidFill>
+                            <a:srgbClr val="000000"/>
+                          </a:solidFill>
+                        </a:rPr>
+                        <a:t>adherence -&gt; change, age -&gt; change, arm -&gt; adherence, arm -&gt; change, baseline -&gt; change</a:t>
+                      </a:r>
+                    </a:p>
+                  </a:txBody>
+                  <a:tcPr/>
+                </a:tc>
+              </a:tr>
+              <a:tr h="236220">
+                <a:tc>
+                  <a:txBody>
+                    <a:bodyPr/>
+                    <a:lstStyle/>
+                    <a:p>
+                      <a:r>
+                        <a:rPr sz="1019" b="0">
+                          <a:solidFill>
+                            <a:srgbClr val="000000"/>
+                          </a:solidFill>
+                        </a:rPr>
+                        <a:t>Identification</a:t>
+                      </a:r>
+                    </a:p>
+                  </a:txBody>
+                  <a:tcPr/>
+                </a:tc>
+                <a:tc>
+                  <a:txBody>
+                    <a:bodyPr/>
+                    <a:lstStyle/>
+                    <a:p>
+                      <a:r>
+                        <a:rPr sz="1019" b="0">
+                          <a:solidFill>
+                            <a:srgbClr val="000000"/>
+                          </a:solidFill>
+                        </a:rPr>
+                        <a:t>graph hash</a:t>
+                      </a:r>
+                    </a:p>
+                  </a:txBody>
+                  <a:tcPr/>
+                </a:tc>
+                <a:tc>
+                  <a:txBody>
+                    <a:bodyPr/>
+                    <a:lstStyle/>
+                    <a:p>
+                      <a:r>
+                        <a:rPr sz="1019" b="0">
+                          <a:solidFill>
+                            <a:srgbClr val="000000"/>
+                          </a:solidFill>
+                        </a:rPr>
+                        <a:t>d02f82660e65</a:t>
+                      </a:r>
+                    </a:p>
+                  </a:txBody>
+                  <a:tcPr/>
+                </a:tc>
+              </a:tr>
+              <a:tr h="236220">
+                <a:tc>
+                  <a:txBody>
+                    <a:bodyPr/>
+                    <a:lstStyle/>
+                    <a:p>
+                      <a:r>
+                        <a:rPr sz="1019" b="0">
+                          <a:solidFill>
+                            <a:srgbClr val="000000"/>
+                          </a:solidFill>
+                        </a:rPr>
+                        <a:t>Identification</a:t>
+                      </a:r>
+                    </a:p>
+                  </a:txBody>
+                  <a:tcPr/>
+                </a:tc>
+                <a:tc>
+                  <a:txBody>
+                    <a:bodyPr/>
+                    <a:lstStyle/>
+                    <a:p>
+                      <a:r>
+                        <a:rPr sz="1019" b="0">
+                          <a:solidFill>
+                            <a:srgbClr val="000000"/>
+                          </a:solidFill>
+                        </a:rPr>
                         <a:t>route</a:t>
                       </a:r>
                     </a:p>
@@ -5024,7 +5519,7 @@
                   <a:tcPr/>
                 </a:tc>
               </a:tr>
-              <a:tr h="262466">
+              <a:tr h="236220">
                 <a:tc>
                   <a:txBody>
                     <a:bodyPr/>
@@ -5077,7 +5572,7 @@
                   <a:tcPr/>
                 </a:tc>
               </a:tr>
-              <a:tr h="262466">
+              <a:tr h="236220">
                 <a:tc>
                   <a:txBody>
                     <a:bodyPr/>
@@ -5130,7 +5625,7 @@
                   <a:tcPr/>
                 </a:tc>
               </a:tr>
-              <a:tr h="262466">
+              <a:tr h="236220">
                 <a:tc>
                   <a:txBody>
                     <a:bodyPr/>
@@ -5183,7 +5678,7 @@
                   <a:tcPr/>
                 </a:tc>
               </a:tr>
-              <a:tr h="262466">
+              <a:tr h="236220">
                 <a:tc>
                   <a:txBody>
                     <a:bodyPr/>
@@ -5236,7 +5731,7 @@
                   <a:tcPr/>
                 </a:tc>
               </a:tr>
-              <a:tr h="262466">
+              <a:tr h="236220">
                 <a:tc>
                   <a:txBody>
                     <a:bodyPr/>
@@ -5289,7 +5784,7 @@
                   <a:tcPr/>
                 </a:tc>
               </a:tr>
-              <a:tr h="262466">
+              <a:tr h="236220">
                 <a:tc>
                   <a:txBody>
                     <a:bodyPr/>
@@ -5342,7 +5837,7 @@
                   <a:tcPr/>
                 </a:tc>
               </a:tr>
-              <a:tr h="262466">
+              <a:tr h="236220">
                 <a:tc>
                   <a:txBody>
                     <a:bodyPr/>
@@ -5395,7 +5890,7 @@
                   <a:tcPr/>
                 </a:tc>
               </a:tr>
-              <a:tr h="262466">
+              <a:tr h="236220">
                 <a:tc>
                   <a:txBody>
                     <a:bodyPr/>
@@ -5448,7 +5943,7 @@
                   <a:tcPr/>
                 </a:tc>
               </a:tr>
-              <a:tr h="262466">
+              <a:tr h="236220">
                 <a:tc>
                   <a:txBody>
                     <a:bodyPr/>
@@ -5501,7 +5996,7 @@
                   <a:tcPr/>
                 </a:tc>
               </a:tr>
-              <a:tr h="262466">
+              <a:tr h="236220">
                 <a:tc>
                   <a:txBody>
                     <a:bodyPr/>
@@ -5554,7 +6049,7 @@
                   <a:tcPr/>
                 </a:tc>
               </a:tr>
-              <a:tr h="262466">
+              <a:tr h="236220">
                 <a:tc>
                   <a:txBody>
                     <a:bodyPr/>
@@ -5607,7 +6102,7 @@
                   <a:tcPr/>
                 </a:tc>
               </a:tr>
-              <a:tr h="262466">
+              <a:tr h="236220">
                 <a:tc>
                   <a:txBody>
                     <a:bodyPr/>
@@ -5660,7 +6155,7 @@
                   <a:tcPr/>
                 </a:tc>
               </a:tr>
-              <a:tr h="262466">
+              <a:tr h="236220">
                 <a:tc>
                   <a:txBody>
                     <a:bodyPr/>
@@ -5713,7 +6208,7 @@
                   <a:tcPr/>
                 </a:tc>
               </a:tr>
-              <a:tr h="262466">
+              <a:tr h="236220">
                 <a:tc>
                   <a:txBody>
                     <a:bodyPr/>
@@ -5766,7 +6261,7 @@
                   <a:tcPr/>
                 </a:tc>
               </a:tr>
-              <a:tr h="262466">
+              <a:tr h="236220">
                 <a:tc>
                   <a:txBody>
                     <a:bodyPr/>
@@ -5819,7 +6314,7 @@
                   <a:tcPr/>
                 </a:tc>
               </a:tr>
-              <a:tr h="262478">
+              <a:tr h="236220">
                 <a:tc>
                   <a:txBody>
                     <a:bodyPr/>
@@ -5884,7 +6379,7 @@
 </p:sld>
 </file>
 
-<file path=ppt/slides/slide15.xml><?xml version="1.0" encoding="utf-8"?>
+<file path=ppt/slides/slide17.xml><?xml version="1.0" encoding="utf-8"?>
 <p:sld xmlns:a="http://schemas.openxmlformats.org/drawingml/2006/main" xmlns:p="http://schemas.openxmlformats.org/presentationml/2006/main" xmlns:r="http://schemas.openxmlformats.org/officeDocument/2006/relationships">
   <p:cSld>
     <p:spTree>
@@ -6622,7 +7117,7 @@
 </p:sld>
 </file>
 
-<file path=ppt/slides/slide16.xml><?xml version="1.0" encoding="utf-8"?>
+<file path=ppt/slides/slide18.xml><?xml version="1.0" encoding="utf-8"?>
 <p:sld xmlns:a="http://schemas.openxmlformats.org/drawingml/2006/main" xmlns:p="http://schemas.openxmlformats.org/presentationml/2006/main" xmlns:r="http://schemas.openxmlformats.org/officeDocument/2006/relationships">
   <p:cSld>
     <p:spTree>
@@ -7154,7 +7649,7 @@
 </p:sld>
 </file>
 
-<file path=ppt/slides/slide17.xml><?xml version="1.0" encoding="utf-8"?>
+<file path=ppt/slides/slide19.xml><?xml version="1.0" encoding="utf-8"?>
 <p:sld xmlns:a="http://schemas.openxmlformats.org/drawingml/2006/main" xmlns:p="http://schemas.openxmlformats.org/presentationml/2006/main" xmlns:r="http://schemas.openxmlformats.org/officeDocument/2006/relationships">
   <p:cSld>
     <p:spTree>
@@ -7249,7 +7744,7 @@
                   <a:srgbClr val="000000"/>
                 </a:solidFill>
               </a:rPr>
-              <a:t>*Figure 1*. Estimated quantities with their intervals. The dashed rule marks the decision threshold; a row whose interval crosses it is unsettled rather than null.</a:t>
+              <a:t>*Figure 1*. The identification graph. A hollow node was not measured and a dashed edge is an unmeasured common cause.</a:t>
             </a:r>
           </a:p>
         </p:txBody>
@@ -7333,21 +7828,39 @@
                   <a:srgbClr val="000000"/>
                 </a:solidFill>
               </a:rPr>
-              <a:t>This report was generated from a recorded analysis. Every quantity in it resolves to that record, and the provenance section names what produced each one.</a:t>
-            </a:r>
-          </a:p>
-        </p:txBody>
-      </p:sp>
-      <p:sp>
-        <p:nvSpPr>
-          <p:cNvPr id="4" name="TextBox 3"/>
+              <a:t>The HYPER-3 study evaluates which of three daily doses should go into phase III and whether any dose harms participants. Across the age strata, 400 adults with elevated or stage-1 hypertension were randomized 2:1:1:1 to standard of care or one of three daily doses, with 100 randomized in band age 25 to 35, 160 in band age 36 to 50, and 140 in band age 51 plus. The target effect of arm on change is identified via the backdoor route, yielding pooled contrasts against control of -5.27 mmHg (90% WALD -6.63 to -3.91 mmHg) for 10 mg, -4.80 mmHg (90% WALD -6.17 to -3.44 mmHg) for 20 mg, and -1.53 mmHg (90% WALD -2.97 to -0.10 mmHg) for 40 mg evaluated against a decision threshold of 0.00 mmHg. For the 40 mg dose, the contrast against control is -5.26 mmHg (90% WALD -8.17 to -2.36 mmHg) in band age 25 to 35 and 6.20 mmHg (90% WALD 3.98 to 8.42 mmHg) in band age 51 plus. Across the trial, 372 units contributed to the primary endpoint, and 0.797 of units remained on study at the final week.</a:t>
+            </a:r>
+          </a:p>
+        </p:txBody>
+      </p:sp>
+    </p:spTree>
+  </p:cSld>
+  <p:clrMapOvr>
+    <a:masterClrMapping/>
+  </p:clrMapOvr>
+</p:sld>
+</file>
+
+<file path=ppt/slides/slide20.xml><?xml version="1.0" encoding="utf-8"?>
+<p:sld xmlns:a="http://schemas.openxmlformats.org/drawingml/2006/main" xmlns:p="http://schemas.openxmlformats.org/presentationml/2006/main" xmlns:r="http://schemas.openxmlformats.org/officeDocument/2006/relationships">
+  <p:cSld>
+    <p:spTree>
+      <p:nvGrpSpPr>
+        <p:cNvPr id="1" name=""/>
+        <p:cNvGrpSpPr/>
+        <p:nvPr/>
+      </p:nvGrpSpPr>
+      <p:grpSpPr/>
+      <p:sp>
+        <p:nvSpPr>
+          <p:cNvPr id="2" name="TextBox 1"/>
           <p:cNvSpPr txBox="1"/>
           <p:nvPr/>
         </p:nvSpPr>
         <p:spPr>
           <a:xfrm>
-            <a:off x="914400" y="1295400"/>
-            <a:ext cx="10363200" cy="508000"/>
+            <a:off x="914400" y="457200"/>
+            <a:ext cx="10363200" cy="431800"/>
           </a:xfrm>
           <a:prstGeom prst="rect">
             <a:avLst/>
@@ -7361,26 +7874,50 @@
           <a:lstStyle/>
           <a:p>
             <a:r>
-              <a:rPr sz="1200" b="0">
+              <a:rPr sz="1200" b="1">
                 <a:solidFill>
                   <a:srgbClr val="000000"/>
                 </a:solidFill>
               </a:rPr>
-              <a:t>Correspondence concerning this report: axiom.</a:t>
-            </a:r>
-          </a:p>
-        </p:txBody>
-      </p:sp>
-      <p:sp>
-        <p:nvSpPr>
-          <p:cNvPr id="5" name="TextBox 4"/>
+              <a:t>Figures (cont.)</a:t>
+            </a:r>
+          </a:p>
+        </p:txBody>
+      </p:sp>
+      <p:pic>
+        <p:nvPicPr>
+          <p:cNvPr id="3" name="Picture 2" descr="image.png"/>
+          <p:cNvPicPr>
+            <a:picLocks noChangeAspect="1"/>
+          </p:cNvPicPr>
+          <p:nvPr/>
+        </p:nvPicPr>
+        <p:blipFill>
+          <a:blip r:embed="rId2"/>
+          <a:stretch>
+            <a:fillRect/>
+          </a:stretch>
+        </p:blipFill>
+        <p:spPr>
+          <a:xfrm>
+            <a:off x="914400" y="965200"/>
+            <a:ext cx="8852023" cy="4978400"/>
+          </a:xfrm>
+          <a:prstGeom prst="rect">
+            <a:avLst/>
+          </a:prstGeom>
+        </p:spPr>
+      </p:pic>
+      <p:sp>
+        <p:nvSpPr>
+          <p:cNvPr id="4" name="TextBox 3"/>
           <p:cNvSpPr txBox="1"/>
           <p:nvPr/>
         </p:nvSpPr>
         <p:spPr>
           <a:xfrm>
-            <a:off x="914400" y="1549400"/>
-            <a:ext cx="10363200" cy="508000"/>
+            <a:off x="914400" y="6035040"/>
+            <a:ext cx="10363200" cy="254000"/>
           </a:xfrm>
           <a:prstGeom prst="rect">
             <a:avLst/>
@@ -7394,12 +7931,12 @@
           <a:lstStyle/>
           <a:p>
             <a:r>
-              <a:rPr sz="1200" b="0">
+              <a:rPr sz="1019" b="0">
                 <a:solidFill>
                   <a:srgbClr val="000000"/>
                 </a:solidFill>
               </a:rPr>
-              <a:t>Running head: HYPER-3</a:t>
+              <a:t>*Figure 2*. Estimated quantities with their intervals. The dashed rule marks the decision threshold; a row whose interval crosses it is unsettled rather than null.</a:t>
             </a:r>
           </a:p>
         </p:txBody>
@@ -7483,7 +8020,7 @@
                   <a:srgbClr val="000000"/>
                 </a:solidFill>
               </a:rPr>
-              <a:t>The trial investigates which of three daily doses should go into phase III and whether any of them harms the people taking it. The effect of arm on change is identified via the backdoor route. Four hundred adults with elevated or stage-1 hypertension were randomized to standard of care or to one of three daily doses, stratified by age band. Seated systolic pressure was measured weekly, averaging readings inside weeks 5 to 8 for safety and weeks 9 to 12 for the primary endpoint. Each dose was compared with control by ANCOVA on the change from baseline, adjusting for baseline pressure and for age band when pooled. The pooled 40 mg versus control contrast is -1.53 mmHg with a 90% WALD interval of -2.97 to -0.10 mmHg. The 20 mg versus control pooled contrast is -4.80 mmHg with a 90% WALD interval of -6.17 to -3.44 mmHg. The 10 mg versus control pooled contrast is -5.27 mmHg with a 90% WALD interval of -6.63 to -3.91 mmHg. For age 51 and older, the 40 mg versus control contrast is 6.20 mmHg with a 90% WALD interval of 3.98 to 8.42 mmHg. For ages 25 to 35, the 40 mg versus control contrast is -5.26 mmHg with a 90% WALD interval of -8.17 to -2.36 mmHg. Dropout is assumed to be ignorable given baseline, and the pooled contrast is assumed to answer the question.</a:t>
+              <a:t>Four hundred adults with elevated or stage-1 hypertension were randomized to evaluate three daily doses against standard of care. The trial addressed which daily dose should advance to phase III and whether any dose harms the participants. The effect of treatment on blood pressure change is identified via the backdoor route identified in the identification graph. The strongest standing assumption is that dropout is ignorable given baseline. The pooled contrasts for 40 mg, 20 mg, and 10 mg each settled below the decision threshold on the favourable side. For the 40 mg dose in participants aged 51 and older, the contrast settled above the threshold on the unfavourable side at 6.20 mmHg (90% WALD 3.98 to 8.42 mmHg), whereas the same dose settled below the threshold in participants aged 25 to 35. These findings indicate that while pooled estimates support advancing the doses, heterogeneity across age strata reveals an unfavorable increase in blood pressure for older participants on the 40 mg dose.</a:t>
             </a:r>
           </a:p>
         </p:txBody>
@@ -7496,7 +8033,7 @@
         </p:nvSpPr>
         <p:spPr>
           <a:xfrm>
-            <a:off x="914400" y="2057400"/>
+            <a:off x="914400" y="1905000"/>
             <a:ext cx="10363200" cy="508000"/>
           </a:xfrm>
           <a:prstGeom prst="rect">
@@ -7516,7 +8053,7 @@
                   <a:srgbClr val="000000"/>
                 </a:solidFill>
               </a:rPr>
-              <a:t>*Reported quantities:* 40 mg vs control, pooled; 20 mg vs control, pooled; 10 mg vs control, pooled; 40 mg vs control, age 51+</a:t>
+              <a:t>Reported quantities: 40 mg vs control, pooled; 20 mg vs control, pooled; 10 mg vs control, pooled; 40 mg vs control, age 51+</a:t>
             </a:r>
           </a:p>
         </p:txBody>
@@ -7600,7 +8137,7 @@
                   <a:srgbClr val="000000"/>
                 </a:solidFill>
               </a:rPr>
-              <a:t>This paper evaluates which of three daily doses should go into phase III, and whether any of them is harming the people taking it. The inquiry centers on the estimated contrasts between the daily doses and the control group. In particular, the decision turns on the pooled contrast comparing 40 mg against control. The reference threshold for evaluating this contrast is 0.00 mmHg. An interval lying wholly on one side of 0.00 mmHg settles the question. An interval that spans 0.00 mmHg indicates that the question remains unsettled. The study also assesses whether any dose inflicts harm across the monitored comparisons. The validity of the resulting conclusions depends directly on underlying conditions. Specifically, two unresolved assumptions carry the analysis throughout. The first assumption is that dropout is ignorable given baseline. The second assumption is that the pooled contrast answers the question. Both assumptions are stated in the methods and revisited in the discussion of limitations.</a:t>
+              <a:t>This report addresses which of three daily doses should go into phase III, and whether any of them is harming the people taking it. The analysis answers this question using 40 mg versus control, pooled. The target quantity is identified. The decision turns on a decision threshold of 0.00 mmHg. An interval that falls entirely on one side of 0.00 mmHg settles the comparison. An interval spanning 0.00 mmHg leaves the question unsettled. Such an interval does not mean there is no effect.</a:t>
             </a:r>
           </a:p>
         </p:txBody>
@@ -7684,7 +8221,7 @@
                   <a:srgbClr val="000000"/>
                 </a:solidFill>
               </a:rPr>
-              <a:t>The study evaluates which of three daily doses should advance to phase III and whether any dose causes harm. The target of inference is the effect of treatment arm on change in blood pressure, identified via the backdoor route. Four hundred adults with elevated or stage-1 hypertension were randomized 2:1:1:1 to standard of care or to one of three daily doses, stratified by age band. To determine which dose to take forward, the design estimates three contrasts against a shared control. Seated systolic pressure was measured weekly. Both endpoints average the readings inside a window—weeks 5–8 for safety and weeks 9–12 for the primary endpoint—rather than using a single visit. Averaging correlated readings reduces endpoint variance, allowing safety boundaries to operate within strata. Each dose was compared with control by ANCOVA on the change from baseline, adjusting for baseline pressure, and for age band when the contrast is pooled across bands. Randomization licenses the intent-to-treat contrast, and adjusting for pre-randomization covariates adds precision without compromising identification. Twelve harm contrasts, comparing each dose against control overall and inside each age band, were evaluated at scheduled safety reviews against a posterior-probability boundary with a 2 mmHg clinical margin. Pre-specifying the age bands as monitored contrasts allows subgroup-specific harms to be detected before the trial ends. The analysis relies on the assumptions that dropout is ignorable given baseline and that the pooled contrast answers the trial question.</a:t>
+              <a:t>To address the question established in the introduction, 400 adults with elevated or stage-1 hypertension were randomized 2:1:1:1 to standard of care or to one of three daily doses, stratified by age band, with the design parameters recorded in Table 1. The protocol estimates three contrasts against a shared control rather than one dose against another. The target is the effect of arm on change, which is identified via the backdoor route shown in Figure 1. This identification turns on the arrows from adherence to change, age to change, arm to adherence, arm to change, and baseline to change. Seated systolic pressure was measured weekly, and both endpoints average the readings inside a window—weeks 5–8 for safety and weeks 9–12 for the primary endpoint—rather than reading a single visit. Averaging several correlated readings roughly halves the variance of a unit's endpoint, which is the difference between a safety boundary that can fire inside a stratum and one that cannot. Each dose was compared with control by ANCOVA on the change from baseline, adjusting for baseline pressure, and adjusting for age band when the contrast is pooled across bands. Randomization licenses the intent-to-treat contrast and nothing else; adjusting for a pre-randomization covariate buys precision at no cost, whereas adjusting for anything measured afterwards would forfeit the identification the randomization provided. Twelve harm contrasts—each dose against control overall and inside each age band—were monitored at scheduled safety reviews against a posterior-probability boundary with a 2 mmHg clinical margin. Pre-specifying the bands as monitored contrasts makes harm within a single age band visible before the trial ends, which no estimator applied at closeout would have found earlier. The analysis relies on two unresolved assumptions, named dropout is ignorable given baseline and the pooled contrast answers the question. What each of these assumptions claims is stated in the limitations section.</a:t>
             </a:r>
           </a:p>
         </p:txBody>
@@ -7697,7 +8234,7 @@
         </p:nvSpPr>
         <p:spPr>
           <a:xfrm>
-            <a:off x="914400" y="2286000"/>
+            <a:off x="914400" y="2590800"/>
             <a:ext cx="10363200" cy="508000"/>
           </a:xfrm>
           <a:prstGeom prst="rect">
@@ -7717,259 +8254,21 @@
                   <a:srgbClr val="000000"/>
                 </a:solidFill>
               </a:rPr>
-              <a:t>Assumptions this analysis rests on</a:t>
-            </a:r>
-          </a:p>
-        </p:txBody>
-      </p:sp>
-      <p:graphicFrame>
-        <p:nvGraphicFramePr>
-          <p:cNvPr id="5" name="Table 4"/>
-          <p:cNvGraphicFramePr>
-            <a:graphicFrameLocks noGrp="1"/>
-          </p:cNvGraphicFramePr>
-          <p:nvPr/>
-        </p:nvGraphicFramePr>
-        <p:xfrm>
-          <a:off x="914400" y="2540000"/>
-          <a:ext cx="10363200" cy="914400"/>
-        </p:xfrm>
-        <a:graphic>
-          <a:graphicData uri="http://schemas.openxmlformats.org/drawingml/2006/table">
-            <a:tbl>
-              <a:tblPr firstRow="1" bandRow="1">
-                <a:tableStyleId>{5C22544A-7EE6-4342-B048-85BDC9FD1C3A}</a:tableStyleId>
-              </a:tblPr>
-              <a:tblGrid>
-                <a:gridCol w="2590800"/>
-                <a:gridCol w="2590800"/>
-                <a:gridCol w="2590800"/>
-                <a:gridCol w="2590800"/>
-              </a:tblGrid>
-              <a:tr h="304800">
-                <a:tc>
-                  <a:txBody>
-                    <a:bodyPr/>
-                    <a:lstStyle/>
-                    <a:p>
-                      <a:r>
-                        <a:rPr sz="1019" b="1">
-                          <a:solidFill>
-                            <a:srgbClr val="000000"/>
-                          </a:solidFill>
-                        </a:rPr>
-                        <a:t>Assumption</a:t>
-                      </a:r>
-                    </a:p>
-                  </a:txBody>
-                  <a:tcPr/>
-                </a:tc>
-                <a:tc>
-                  <a:txBody>
-                    <a:bodyPr/>
-                    <a:lstStyle/>
-                    <a:p>
-                      <a:r>
-                        <a:rPr sz="1019" b="1">
-                          <a:solidFill>
-                            <a:srgbClr val="000000"/>
-                          </a:solidFill>
-                        </a:rPr>
-                        <a:t>Statement</a:t>
-                      </a:r>
-                    </a:p>
-                  </a:txBody>
-                  <a:tcPr/>
-                </a:tc>
-                <a:tc>
-                  <a:txBody>
-                    <a:bodyPr/>
-                    <a:lstStyle/>
-                    <a:p>
-                      <a:r>
-                        <a:rPr sz="1019" b="1">
-                          <a:solidFill>
-                            <a:srgbClr val="000000"/>
-                          </a:solidFill>
-                        </a:rPr>
-                        <a:t>Status</a:t>
-                      </a:r>
-                    </a:p>
-                  </a:txBody>
-                  <a:tcPr/>
-                </a:tc>
-                <a:tc>
-                  <a:txBody>
-                    <a:bodyPr/>
-                    <a:lstStyle/>
-                    <a:p>
-                      <a:r>
-                        <a:rPr sz="1019" b="1">
-                          <a:solidFill>
-                            <a:srgbClr val="000000"/>
-                          </a:solidFill>
-                        </a:rPr>
-                        <a:t>Challenged by</a:t>
-                      </a:r>
-                    </a:p>
-                  </a:txBody>
-                  <a:tcPr/>
-                </a:tc>
-              </a:tr>
-              <a:tr h="304800">
-                <a:tc>
-                  <a:txBody>
-                    <a:bodyPr/>
-                    <a:lstStyle/>
-                    <a:p>
-                      <a:r>
-                        <a:rPr sz="1019" b="0">
-                          <a:solidFill>
-                            <a:srgbClr val="000000"/>
-                          </a:solidFill>
-                        </a:rPr>
-                        <a:t>dropout is ignorable given baseline</a:t>
-                      </a:r>
-                    </a:p>
-                  </a:txBody>
-                  <a:tcPr/>
-                </a:tc>
-                <a:tc>
-                  <a:txBody>
-                    <a:bodyPr/>
-                    <a:lstStyle/>
-                    <a:p>
-                      <a:r>
-                        <a:rPr sz="1019" b="0">
-                          <a:solidFill>
-                            <a:srgbClr val="000000"/>
-                          </a:solidFill>
-                        </a:rPr>
-                        <a:t>units who left the study differ from those who stayed only through what was measured before randomization</a:t>
-                      </a:r>
-                    </a:p>
-                  </a:txBody>
-                  <a:tcPr/>
-                </a:tc>
-                <a:tc>
-                  <a:txBody>
-                    <a:bodyPr/>
-                    <a:lstStyle/>
-                    <a:p>
-                      <a:r>
-                        <a:rPr sz="1019" b="0">
-                          <a:solidFill>
-                            <a:srgbClr val="000000"/>
-                          </a:solidFill>
-                        </a:rPr>
-                        <a:t>is assumed and has not been checked</a:t>
-                      </a:r>
-                    </a:p>
-                  </a:txBody>
-                  <a:tcPr/>
-                </a:tc>
-                <a:tc>
-                  <a:txBody>
-                    <a:bodyPr/>
-                    <a:lstStyle/>
-                    <a:p>
-                      <a:r>
-                        <a:rPr sz="1019" b="0">
-                          <a:solidFill>
-                            <a:srgbClr val="000000"/>
-                          </a:solidFill>
-                        </a:rPr>
-                        <a:t>a tipping-point analysis over plausible departures from ignorability</a:t>
-                      </a:r>
-                    </a:p>
-                  </a:txBody>
-                  <a:tcPr/>
-                </a:tc>
-              </a:tr>
-              <a:tr h="304800">
-                <a:tc>
-                  <a:txBody>
-                    <a:bodyPr/>
-                    <a:lstStyle/>
-                    <a:p>
-                      <a:r>
-                        <a:rPr sz="1019" b="0">
-                          <a:solidFill>
-                            <a:srgbClr val="000000"/>
-                          </a:solidFill>
-                        </a:rPr>
-                        <a:t>the pooled contrast answers the question</a:t>
-                      </a:r>
-                    </a:p>
-                  </a:txBody>
-                  <a:tcPr/>
-                </a:tc>
-                <a:tc>
-                  <a:txBody>
-                    <a:bodyPr/>
-                    <a:lstStyle/>
-                    <a:p>
-                      <a:r>
-                        <a:rPr sz="1019" b="0">
-                          <a:solidFill>
-                            <a:srgbClr val="000000"/>
-                          </a:solidFill>
-                        </a:rPr>
-                        <a:t>a single number over all age bands describes the effect the decision is about</a:t>
-                      </a:r>
-                    </a:p>
-                  </a:txBody>
-                  <a:tcPr/>
-                </a:tc>
-                <a:tc>
-                  <a:txBody>
-                    <a:bodyPr/>
-                    <a:lstStyle/>
-                    <a:p>
-                      <a:r>
-                        <a:rPr sz="1019" b="0">
-                          <a:solidFill>
-                            <a:srgbClr val="000000"/>
-                          </a:solidFill>
-                        </a:rPr>
-                        <a:t>is known to fail</a:t>
-                      </a:r>
-                    </a:p>
-                  </a:txBody>
-                  <a:tcPr/>
-                </a:tc>
-                <a:tc>
-                  <a:txBody>
-                    <a:bodyPr/>
-                    <a:lstStyle/>
-                    <a:p>
-                      <a:r>
-                        <a:rPr sz="1019" b="0">
-                          <a:solidFill>
-                            <a:srgbClr val="000000"/>
-                          </a:solidFill>
-                        </a:rPr>
-                        <a:t>heterogeneity across the pre-specified strata</a:t>
-                      </a:r>
-                    </a:p>
-                  </a:txBody>
-                  <a:tcPr/>
-                </a:tc>
-              </a:tr>
-            </a:tbl>
-          </a:graphicData>
-        </a:graphic>
-      </p:graphicFrame>
-      <p:sp>
-        <p:nvSpPr>
-          <p:cNvPr id="6" name="TextBox 5"/>
+              <a:t>Protocol</a:t>
+            </a:r>
+          </a:p>
+        </p:txBody>
+      </p:sp>
+      <p:sp>
+        <p:nvSpPr>
+          <p:cNvPr id="5" name="TextBox 4"/>
           <p:cNvSpPr txBox="1"/>
           <p:nvPr/>
         </p:nvSpPr>
         <p:spPr>
           <a:xfrm>
-            <a:off x="914400" y="3606800"/>
-            <a:ext cx="10363200" cy="2336800"/>
+            <a:off x="914400" y="2844800"/>
+            <a:ext cx="10363200" cy="508000"/>
           </a:xfrm>
           <a:prstGeom prst="rect">
             <a:avLst/>
@@ -7983,38 +8282,81 @@
           <a:lstStyle/>
           <a:p>
             <a:r>
-              <a:rPr sz="1019" b="1">
+              <a:rPr sz="1200" b="0">
                 <a:solidFill>
                   <a:srgbClr val="000000"/>
                 </a:solidFill>
               </a:rPr>
-              <a:t>assumption  </a:t>
-            </a:r>
-            <a:r>
-              <a:rPr sz="1080" b="0">
+              <a:t>`arm_i ~ blocked randomization within age band, allocation 2:1:1:1`</a:t>
+            </a:r>
+          </a:p>
+        </p:txBody>
+      </p:sp>
+      <p:sp>
+        <p:nvSpPr>
+          <p:cNvPr id="6" name="TextBox 5"/>
+          <p:cNvSpPr txBox="1"/>
+          <p:nvPr/>
+        </p:nvSpPr>
+        <p:spPr>
+          <a:xfrm>
+            <a:off x="914400" y="3098800"/>
+            <a:ext cx="10363200" cy="508000"/>
+          </a:xfrm>
+          <a:prstGeom prst="rect">
+            <a:avLst/>
+          </a:prstGeom>
+          <a:noFill/>
+        </p:spPr>
+        <p:txBody>
+          <a:bodyPr wrap="square">
+            <a:spAutoFit/>
+          </a:bodyPr>
+          <a:lstStyle/>
+          <a:p>
+            <a:r>
+              <a:rPr sz="1200" b="1">
                 <a:solidFill>
                   <a:srgbClr val="000000"/>
                 </a:solidFill>
               </a:rPr>
-              <a:t>Adherence was not adjusted for: it lies on the path from arm to outcome, and conditioning on it would break the randomization.</a:t>
-            </a:r>
-          </a:p>
-          <a:p>
-            <a:r>
-              <a:rPr sz="1019" b="1">
+              <a:t>Analysis</a:t>
+            </a:r>
+          </a:p>
+        </p:txBody>
+      </p:sp>
+      <p:sp>
+        <p:nvSpPr>
+          <p:cNvPr id="7" name="TextBox 6"/>
+          <p:cNvSpPr txBox="1"/>
+          <p:nvPr/>
+        </p:nvSpPr>
+        <p:spPr>
+          <a:xfrm>
+            <a:off x="914400" y="3352800"/>
+            <a:ext cx="10363200" cy="508000"/>
+          </a:xfrm>
+          <a:prstGeom prst="rect">
+            <a:avLst/>
+          </a:prstGeom>
+          <a:noFill/>
+        </p:spPr>
+        <p:txBody>
+          <a:bodyPr wrap="square">
+            <a:spAutoFit/>
+          </a:bodyPr>
+          <a:lstStyle/>
+          <a:p>
+            <a:r>
+              <a:rPr sz="1200" b="0">
                 <a:solidFill>
                   <a:srgbClr val="000000"/>
                 </a:solidFill>
               </a:rPr>
-              <a:t>assumption  </a:t>
-            </a:r>
-            <a:r>
-              <a:rPr sz="1080" b="0">
-                <a:solidFill>
-                  <a:srgbClr val="000000"/>
-                </a:solidFill>
-              </a:rPr>
-              <a:t>The pooled 40 mg contrast is reported alongside the per-band contrasts, never instead of them.</a:t>
+              <a:t>`change_i = beta0 + tau * treated_i + beta1 * baseline_i + eps_i`
+`  pooled, add:  + sum_b gamma_b * 1[age_band_i = b]`
+`  change_i   = mean(SBP_i, weeks 9-12) - SBP_i(baseline)`
+`  tau        = the contrast reported; treated_i = 1 for the dose arm`</a:t>
             </a:r>
           </a:p>
         </p:txBody>
@@ -8065,7 +8407,7 @@
                   <a:srgbClr val="000000"/>
                 </a:solidFill>
               </a:rPr>
-              <a:t>Results</a:t>
+              <a:t>Methods (cont.)</a:t>
             </a:r>
           </a:p>
         </p:txBody>
@@ -8079,218 +8421,6 @@
         <p:spPr>
           <a:xfrm>
             <a:off x="914400" y="965200"/>
-            <a:ext cx="2489200" cy="889000"/>
-          </a:xfrm>
-          <a:prstGeom prst="rect">
-            <a:avLst/>
-          </a:prstGeom>
-          <a:noFill/>
-        </p:spPr>
-        <p:txBody>
-          <a:bodyPr wrap="square">
-            <a:spAutoFit/>
-          </a:bodyPr>
-          <a:lstStyle/>
-          <a:p>
-            <a:r>
-              <a:rPr sz="1019" b="0">
-                <a:solidFill>
-                  <a:srgbClr val="000000"/>
-                </a:solidFill>
-              </a:rPr>
-              <a:t>40 MG VS CONTROL, POOLED</a:t>
-            </a:r>
-          </a:p>
-          <a:p>
-            <a:r>
-              <a:rPr sz="960" b="1">
-                <a:solidFill>
-                  <a:srgbClr val="000000"/>
-                </a:solidFill>
-              </a:rPr>
-              <a:t>-1.53 mmHg</a:t>
-            </a:r>
-          </a:p>
-          <a:p>
-            <a:r>
-              <a:rPr sz="1019" b="0">
-                <a:solidFill>
-                  <a:srgbClr val="000000"/>
-                </a:solidFill>
-              </a:rPr>
-              <a:t>[-2.965, -0.1035] (90% WALD)</a:t>
-            </a:r>
-          </a:p>
-        </p:txBody>
-      </p:sp>
-      <p:sp>
-        <p:nvSpPr>
-          <p:cNvPr id="4" name="TextBox 3"/>
-          <p:cNvSpPr txBox="1"/>
-          <p:nvPr/>
-        </p:nvSpPr>
-        <p:spPr>
-          <a:xfrm>
-            <a:off x="3505200" y="965200"/>
-            <a:ext cx="2489200" cy="889000"/>
-          </a:xfrm>
-          <a:prstGeom prst="rect">
-            <a:avLst/>
-          </a:prstGeom>
-          <a:noFill/>
-        </p:spPr>
-        <p:txBody>
-          <a:bodyPr wrap="square">
-            <a:spAutoFit/>
-          </a:bodyPr>
-          <a:lstStyle/>
-          <a:p>
-            <a:r>
-              <a:rPr sz="1019" b="0">
-                <a:solidFill>
-                  <a:srgbClr val="000000"/>
-                </a:solidFill>
-              </a:rPr>
-              <a:t>20 MG VS CONTROL, POOLED</a:t>
-            </a:r>
-          </a:p>
-          <a:p>
-            <a:r>
-              <a:rPr sz="960" b="1">
-                <a:solidFill>
-                  <a:srgbClr val="000000"/>
-                </a:solidFill>
-              </a:rPr>
-              <a:t>-4.80 mmHg</a:t>
-            </a:r>
-          </a:p>
-          <a:p>
-            <a:r>
-              <a:rPr sz="1019" b="0">
-                <a:solidFill>
-                  <a:srgbClr val="000000"/>
-                </a:solidFill>
-              </a:rPr>
-              <a:t>[-6.171, -3.437] (90% WALD)</a:t>
-            </a:r>
-          </a:p>
-        </p:txBody>
-      </p:sp>
-      <p:sp>
-        <p:nvSpPr>
-          <p:cNvPr id="5" name="TextBox 4"/>
-          <p:cNvSpPr txBox="1"/>
-          <p:nvPr/>
-        </p:nvSpPr>
-        <p:spPr>
-          <a:xfrm>
-            <a:off x="6096000" y="965200"/>
-            <a:ext cx="2489200" cy="889000"/>
-          </a:xfrm>
-          <a:prstGeom prst="rect">
-            <a:avLst/>
-          </a:prstGeom>
-          <a:noFill/>
-        </p:spPr>
-        <p:txBody>
-          <a:bodyPr wrap="square">
-            <a:spAutoFit/>
-          </a:bodyPr>
-          <a:lstStyle/>
-          <a:p>
-            <a:r>
-              <a:rPr sz="1019" b="0">
-                <a:solidFill>
-                  <a:srgbClr val="000000"/>
-                </a:solidFill>
-              </a:rPr>
-              <a:t>10 MG VS CONTROL, POOLED</a:t>
-            </a:r>
-          </a:p>
-          <a:p>
-            <a:r>
-              <a:rPr sz="960" b="1">
-                <a:solidFill>
-                  <a:srgbClr val="000000"/>
-                </a:solidFill>
-              </a:rPr>
-              <a:t>-5.27 mmHg</a:t>
-            </a:r>
-          </a:p>
-          <a:p>
-            <a:r>
-              <a:rPr sz="1019" b="0">
-                <a:solidFill>
-                  <a:srgbClr val="000000"/>
-                </a:solidFill>
-              </a:rPr>
-              <a:t>[-6.631, -3.907] (90% WALD)</a:t>
-            </a:r>
-          </a:p>
-        </p:txBody>
-      </p:sp>
-      <p:sp>
-        <p:nvSpPr>
-          <p:cNvPr id="6" name="TextBox 5"/>
-          <p:cNvSpPr txBox="1"/>
-          <p:nvPr/>
-        </p:nvSpPr>
-        <p:spPr>
-          <a:xfrm>
-            <a:off x="8686800" y="965200"/>
-            <a:ext cx="2489200" cy="889000"/>
-          </a:xfrm>
-          <a:prstGeom prst="rect">
-            <a:avLst/>
-          </a:prstGeom>
-          <a:noFill/>
-        </p:spPr>
-        <p:txBody>
-          <a:bodyPr wrap="square">
-            <a:spAutoFit/>
-          </a:bodyPr>
-          <a:lstStyle/>
-          <a:p>
-            <a:r>
-              <a:rPr sz="1019" b="0">
-                <a:solidFill>
-                  <a:srgbClr val="000000"/>
-                </a:solidFill>
-              </a:rPr>
-              <a:t>40 MG VS CONTROL, AGE 51+</a:t>
-            </a:r>
-          </a:p>
-          <a:p>
-            <a:r>
-              <a:rPr sz="960" b="1">
-                <a:solidFill>
-                  <a:srgbClr val="000000"/>
-                </a:solidFill>
-              </a:rPr>
-              <a:t>6.20 mmHg</a:t>
-            </a:r>
-          </a:p>
-          <a:p>
-            <a:r>
-              <a:rPr sz="1019" b="0">
-                <a:solidFill>
-                  <a:srgbClr val="000000"/>
-                </a:solidFill>
-              </a:rPr>
-              <a:t>[3.985, 8.424] (90% WALD)</a:t>
-            </a:r>
-          </a:p>
-        </p:txBody>
-      </p:sp>
-      <p:sp>
-        <p:nvSpPr>
-          <p:cNvPr id="7" name="TextBox 6"/>
-          <p:cNvSpPr txBox="1"/>
-          <p:nvPr/>
-        </p:nvSpPr>
-        <p:spPr>
-          <a:xfrm>
-            <a:off x="914400" y="2006600"/>
             <a:ext cx="10363200" cy="508000"/>
           </a:xfrm>
           <a:prstGeom prst="rect">
@@ -8305,12 +8435,561 @@
           <a:lstStyle/>
           <a:p>
             <a:r>
+              <a:rPr sz="1200" b="1">
+                <a:solidFill>
+                  <a:srgbClr val="000000"/>
+                </a:solidFill>
+              </a:rPr>
+              <a:t>Safety monitoring</a:t>
+            </a:r>
+          </a:p>
+        </p:txBody>
+      </p:sp>
+      <p:sp>
+        <p:nvSpPr>
+          <p:cNvPr id="4" name="TextBox 3"/>
+          <p:cNvSpPr txBox="1"/>
+          <p:nvPr/>
+        </p:nvSpPr>
+        <p:spPr>
+          <a:xfrm>
+            <a:off x="914400" y="1219200"/>
+            <a:ext cx="10363200" cy="508000"/>
+          </a:xfrm>
+          <a:prstGeom prst="rect">
+            <a:avLst/>
+          </a:prstGeom>
+          <a:noFill/>
+        </p:spPr>
+        <p:txBody>
+          <a:bodyPr wrap="square">
+            <a:spAutoFit/>
+          </a:bodyPr>
+          <a:lstStyle/>
+          <a:p>
+            <a:r>
               <a:rPr sz="1200" b="0">
                 <a:solidFill>
                   <a:srgbClr val="000000"/>
                 </a:solidFill>
               </a:rPr>
-              <a:t>The pooled contrast for 40 mg versus control is -1.53 mmHg (90% WALD -2.97 to -0.10 mmHg). For the stratum of participants aged 51 and older, the contrast for 40 mg versus control is 6.20 mmHg (90% WALD 3.98 to 8.42 mmHg).</a:t>
+              <a:t>`stop for harm at look k when`
+`  P(tau_g &gt; delta | data_k) &gt; b_k     for any monitored contrast g`
+`  delta = the clinical margin; b_k = the boundary at look k`</a:t>
+            </a:r>
+          </a:p>
+        </p:txBody>
+      </p:sp>
+      <p:sp>
+        <p:nvSpPr>
+          <p:cNvPr id="5" name="TextBox 4"/>
+          <p:cNvSpPr txBox="1"/>
+          <p:nvPr/>
+        </p:nvSpPr>
+        <p:spPr>
+          <a:xfrm>
+            <a:off x="914400" y="1701800"/>
+            <a:ext cx="10363200" cy="508000"/>
+          </a:xfrm>
+          <a:prstGeom prst="rect">
+            <a:avLst/>
+          </a:prstGeom>
+          <a:noFill/>
+        </p:spPr>
+        <p:txBody>
+          <a:bodyPr wrap="square">
+            <a:spAutoFit/>
+          </a:bodyPr>
+          <a:lstStyle/>
+          <a:p>
+            <a:r>
+              <a:rPr sz="1200" b="1">
+                <a:solidFill>
+                  <a:srgbClr val="000000"/>
+                </a:solidFill>
+              </a:rPr>
+              <a:t>The identification graph</a:t>
+            </a:r>
+          </a:p>
+        </p:txBody>
+      </p:sp>
+      <p:graphicFrame>
+        <p:nvGraphicFramePr>
+          <p:cNvPr id="6" name="Table 5"/>
+          <p:cNvGraphicFramePr>
+            <a:graphicFrameLocks noGrp="1"/>
+          </p:cNvGraphicFramePr>
+          <p:nvPr/>
+        </p:nvGraphicFramePr>
+        <p:xfrm>
+          <a:off x="914400" y="1955800"/>
+          <a:ext cx="10363200" cy="1828800"/>
+        </p:xfrm>
+        <a:graphic>
+          <a:graphicData uri="http://schemas.openxmlformats.org/drawingml/2006/table">
+            <a:tbl>
+              <a:tblPr firstRow="1" bandRow="1">
+                <a:tableStyleId>{5C22544A-7EE6-4342-B048-85BDC9FD1C3A}</a:tableStyleId>
+              </a:tblPr>
+              <a:tblGrid>
+                <a:gridCol w="2590800"/>
+                <a:gridCol w="2590800"/>
+                <a:gridCol w="2590800"/>
+                <a:gridCol w="2590800"/>
+              </a:tblGrid>
+              <a:tr h="304800">
+                <a:tc>
+                  <a:txBody>
+                    <a:bodyPr/>
+                    <a:lstStyle/>
+                    <a:p>
+                      <a:r>
+                        <a:rPr sz="1019" b="1">
+                          <a:solidFill>
+                            <a:srgbClr val="000000"/>
+                          </a:solidFill>
+                        </a:rPr>
+                        <a:t>From</a:t>
+                      </a:r>
+                    </a:p>
+                  </a:txBody>
+                  <a:tcPr/>
+                </a:tc>
+                <a:tc>
+                  <a:txBody>
+                    <a:bodyPr/>
+                    <a:lstStyle/>
+                    <a:p>
+                      <a:r>
+                        <a:rPr sz="1019" b="1">
+                          <a:solidFill>
+                            <a:srgbClr val="000000"/>
+                          </a:solidFill>
+                        </a:rPr>
+                        <a:t>Arrow</a:t>
+                      </a:r>
+                    </a:p>
+                  </a:txBody>
+                  <a:tcPr/>
+                </a:tc>
+                <a:tc>
+                  <a:txBody>
+                    <a:bodyPr/>
+                    <a:lstStyle/>
+                    <a:p>
+                      <a:r>
+                        <a:rPr sz="1019" b="1">
+                          <a:solidFill>
+                            <a:srgbClr val="000000"/>
+                          </a:solidFill>
+                        </a:rPr>
+                        <a:t>To</a:t>
+                      </a:r>
+                    </a:p>
+                  </a:txBody>
+                  <a:tcPr/>
+                </a:tc>
+                <a:tc>
+                  <a:txBody>
+                    <a:bodyPr/>
+                    <a:lstStyle/>
+                    <a:p>
+                      <a:r>
+                        <a:rPr sz="1019" b="1">
+                          <a:solidFill>
+                            <a:srgbClr val="000000"/>
+                          </a:solidFill>
+                        </a:rPr>
+                        <a:t>Kind</a:t>
+                      </a:r>
+                    </a:p>
+                  </a:txBody>
+                  <a:tcPr/>
+                </a:tc>
+              </a:tr>
+              <a:tr h="304800">
+                <a:tc>
+                  <a:txBody>
+                    <a:bodyPr/>
+                    <a:lstStyle/>
+                    <a:p>
+                      <a:r>
+                        <a:rPr sz="1019" b="0">
+                          <a:solidFill>
+                            <a:srgbClr val="000000"/>
+                          </a:solidFill>
+                        </a:rPr>
+                        <a:t>adherence</a:t>
+                      </a:r>
+                    </a:p>
+                  </a:txBody>
+                  <a:tcPr/>
+                </a:tc>
+                <a:tc>
+                  <a:txBody>
+                    <a:bodyPr/>
+                    <a:lstStyle/>
+                    <a:p>
+                      <a:r>
+                        <a:rPr sz="1019" b="0">
+                          <a:solidFill>
+                            <a:srgbClr val="000000"/>
+                          </a:solidFill>
+                        </a:rPr>
+                        <a:t>→</a:t>
+                      </a:r>
+                    </a:p>
+                  </a:txBody>
+                  <a:tcPr/>
+                </a:tc>
+                <a:tc>
+                  <a:txBody>
+                    <a:bodyPr/>
+                    <a:lstStyle/>
+                    <a:p>
+                      <a:r>
+                        <a:rPr sz="1019" b="0">
+                          <a:solidFill>
+                            <a:srgbClr val="000000"/>
+                          </a:solidFill>
+                        </a:rPr>
+                        <a:t>change</a:t>
+                      </a:r>
+                    </a:p>
+                  </a:txBody>
+                  <a:tcPr/>
+                </a:tc>
+                <a:tc>
+                  <a:txBody>
+                    <a:bodyPr/>
+                    <a:lstStyle/>
+                    <a:p>
+                      <a:r>
+                        <a:rPr sz="1019" b="0">
+                          <a:solidFill>
+                            <a:srgbClr val="000000"/>
+                          </a:solidFill>
+                        </a:rPr>
+                        <a:t>direct effect</a:t>
+                      </a:r>
+                    </a:p>
+                  </a:txBody>
+                  <a:tcPr/>
+                </a:tc>
+              </a:tr>
+              <a:tr h="304800">
+                <a:tc>
+                  <a:txBody>
+                    <a:bodyPr/>
+                    <a:lstStyle/>
+                    <a:p>
+                      <a:r>
+                        <a:rPr sz="1019" b="0">
+                          <a:solidFill>
+                            <a:srgbClr val="000000"/>
+                          </a:solidFill>
+                        </a:rPr>
+                        <a:t>age</a:t>
+                      </a:r>
+                    </a:p>
+                  </a:txBody>
+                  <a:tcPr/>
+                </a:tc>
+                <a:tc>
+                  <a:txBody>
+                    <a:bodyPr/>
+                    <a:lstStyle/>
+                    <a:p>
+                      <a:r>
+                        <a:rPr sz="1019" b="0">
+                          <a:solidFill>
+                            <a:srgbClr val="000000"/>
+                          </a:solidFill>
+                        </a:rPr>
+                        <a:t>→</a:t>
+                      </a:r>
+                    </a:p>
+                  </a:txBody>
+                  <a:tcPr/>
+                </a:tc>
+                <a:tc>
+                  <a:txBody>
+                    <a:bodyPr/>
+                    <a:lstStyle/>
+                    <a:p>
+                      <a:r>
+                        <a:rPr sz="1019" b="0">
+                          <a:solidFill>
+                            <a:srgbClr val="000000"/>
+                          </a:solidFill>
+                        </a:rPr>
+                        <a:t>change</a:t>
+                      </a:r>
+                    </a:p>
+                  </a:txBody>
+                  <a:tcPr/>
+                </a:tc>
+                <a:tc>
+                  <a:txBody>
+                    <a:bodyPr/>
+                    <a:lstStyle/>
+                    <a:p>
+                      <a:r>
+                        <a:rPr sz="1019" b="0">
+                          <a:solidFill>
+                            <a:srgbClr val="000000"/>
+                          </a:solidFill>
+                        </a:rPr>
+                        <a:t>direct effect</a:t>
+                      </a:r>
+                    </a:p>
+                  </a:txBody>
+                  <a:tcPr/>
+                </a:tc>
+              </a:tr>
+              <a:tr h="304800">
+                <a:tc>
+                  <a:txBody>
+                    <a:bodyPr/>
+                    <a:lstStyle/>
+                    <a:p>
+                      <a:r>
+                        <a:rPr sz="1019" b="0">
+                          <a:solidFill>
+                            <a:srgbClr val="000000"/>
+                          </a:solidFill>
+                        </a:rPr>
+                        <a:t>arm</a:t>
+                      </a:r>
+                    </a:p>
+                  </a:txBody>
+                  <a:tcPr/>
+                </a:tc>
+                <a:tc>
+                  <a:txBody>
+                    <a:bodyPr/>
+                    <a:lstStyle/>
+                    <a:p>
+                      <a:r>
+                        <a:rPr sz="1019" b="0">
+                          <a:solidFill>
+                            <a:srgbClr val="000000"/>
+                          </a:solidFill>
+                        </a:rPr>
+                        <a:t>→</a:t>
+                      </a:r>
+                    </a:p>
+                  </a:txBody>
+                  <a:tcPr/>
+                </a:tc>
+                <a:tc>
+                  <a:txBody>
+                    <a:bodyPr/>
+                    <a:lstStyle/>
+                    <a:p>
+                      <a:r>
+                        <a:rPr sz="1019" b="0">
+                          <a:solidFill>
+                            <a:srgbClr val="000000"/>
+                          </a:solidFill>
+                        </a:rPr>
+                        <a:t>adherence</a:t>
+                      </a:r>
+                    </a:p>
+                  </a:txBody>
+                  <a:tcPr/>
+                </a:tc>
+                <a:tc>
+                  <a:txBody>
+                    <a:bodyPr/>
+                    <a:lstStyle/>
+                    <a:p>
+                      <a:r>
+                        <a:rPr sz="1019" b="0">
+                          <a:solidFill>
+                            <a:srgbClr val="000000"/>
+                          </a:solidFill>
+                        </a:rPr>
+                        <a:t>direct effect</a:t>
+                      </a:r>
+                    </a:p>
+                  </a:txBody>
+                  <a:tcPr/>
+                </a:tc>
+              </a:tr>
+              <a:tr h="304800">
+                <a:tc>
+                  <a:txBody>
+                    <a:bodyPr/>
+                    <a:lstStyle/>
+                    <a:p>
+                      <a:r>
+                        <a:rPr sz="1019" b="0">
+                          <a:solidFill>
+                            <a:srgbClr val="000000"/>
+                          </a:solidFill>
+                        </a:rPr>
+                        <a:t>arm</a:t>
+                      </a:r>
+                    </a:p>
+                  </a:txBody>
+                  <a:tcPr/>
+                </a:tc>
+                <a:tc>
+                  <a:txBody>
+                    <a:bodyPr/>
+                    <a:lstStyle/>
+                    <a:p>
+                      <a:r>
+                        <a:rPr sz="1019" b="0">
+                          <a:solidFill>
+                            <a:srgbClr val="000000"/>
+                          </a:solidFill>
+                        </a:rPr>
+                        <a:t>→</a:t>
+                      </a:r>
+                    </a:p>
+                  </a:txBody>
+                  <a:tcPr/>
+                </a:tc>
+                <a:tc>
+                  <a:txBody>
+                    <a:bodyPr/>
+                    <a:lstStyle/>
+                    <a:p>
+                      <a:r>
+                        <a:rPr sz="1019" b="0">
+                          <a:solidFill>
+                            <a:srgbClr val="000000"/>
+                          </a:solidFill>
+                        </a:rPr>
+                        <a:t>change</a:t>
+                      </a:r>
+                    </a:p>
+                  </a:txBody>
+                  <a:tcPr/>
+                </a:tc>
+                <a:tc>
+                  <a:txBody>
+                    <a:bodyPr/>
+                    <a:lstStyle/>
+                    <a:p>
+                      <a:r>
+                        <a:rPr sz="1019" b="0">
+                          <a:solidFill>
+                            <a:srgbClr val="000000"/>
+                          </a:solidFill>
+                        </a:rPr>
+                        <a:t>direct effect</a:t>
+                      </a:r>
+                    </a:p>
+                  </a:txBody>
+                  <a:tcPr/>
+                </a:tc>
+              </a:tr>
+              <a:tr h="304800">
+                <a:tc>
+                  <a:txBody>
+                    <a:bodyPr/>
+                    <a:lstStyle/>
+                    <a:p>
+                      <a:r>
+                        <a:rPr sz="1019" b="0">
+                          <a:solidFill>
+                            <a:srgbClr val="000000"/>
+                          </a:solidFill>
+                        </a:rPr>
+                        <a:t>baseline</a:t>
+                      </a:r>
+                    </a:p>
+                  </a:txBody>
+                  <a:tcPr/>
+                </a:tc>
+                <a:tc>
+                  <a:txBody>
+                    <a:bodyPr/>
+                    <a:lstStyle/>
+                    <a:p>
+                      <a:r>
+                        <a:rPr sz="1019" b="0">
+                          <a:solidFill>
+                            <a:srgbClr val="000000"/>
+                          </a:solidFill>
+                        </a:rPr>
+                        <a:t>→</a:t>
+                      </a:r>
+                    </a:p>
+                  </a:txBody>
+                  <a:tcPr/>
+                </a:tc>
+                <a:tc>
+                  <a:txBody>
+                    <a:bodyPr/>
+                    <a:lstStyle/>
+                    <a:p>
+                      <a:r>
+                        <a:rPr sz="1019" b="0">
+                          <a:solidFill>
+                            <a:srgbClr val="000000"/>
+                          </a:solidFill>
+                        </a:rPr>
+                        <a:t>change</a:t>
+                      </a:r>
+                    </a:p>
+                  </a:txBody>
+                  <a:tcPr/>
+                </a:tc>
+                <a:tc>
+                  <a:txBody>
+                    <a:bodyPr/>
+                    <a:lstStyle/>
+                    <a:p>
+                      <a:r>
+                        <a:rPr sz="1019" b="0">
+                          <a:solidFill>
+                            <a:srgbClr val="000000"/>
+                          </a:solidFill>
+                        </a:rPr>
+                        <a:t>direct effect</a:t>
+                      </a:r>
+                    </a:p>
+                  </a:txBody>
+                  <a:tcPr/>
+                </a:tc>
+              </a:tr>
+            </a:tbl>
+          </a:graphicData>
+        </a:graphic>
+      </p:graphicFrame>
+      <p:sp>
+        <p:nvSpPr>
+          <p:cNvPr id="7" name="TextBox 6"/>
+          <p:cNvSpPr txBox="1"/>
+          <p:nvPr/>
+        </p:nvSpPr>
+        <p:spPr>
+          <a:xfrm>
+            <a:off x="914400" y="3937000"/>
+            <a:ext cx="10363200" cy="508000"/>
+          </a:xfrm>
+          <a:prstGeom prst="rect">
+            <a:avLst/>
+          </a:prstGeom>
+          <a:noFill/>
+        </p:spPr>
+        <p:txBody>
+          <a:bodyPr wrap="square">
+            <a:spAutoFit/>
+          </a:bodyPr>
+          <a:lstStyle/>
+          <a:p>
+            <a:r>
+              <a:rPr sz="1200" b="1">
+                <a:solidFill>
+                  <a:srgbClr val="000000"/>
+                </a:solidFill>
+              </a:rPr>
+              <a:t>Assumptions this analysis rests on</a:t>
             </a:r>
           </a:p>
         </p:txBody>
@@ -8361,21 +9040,259 @@
                   <a:srgbClr val="000000"/>
                 </a:solidFill>
               </a:rPr>
-              <a:t>Results (cont.)</a:t>
-            </a:r>
-          </a:p>
-        </p:txBody>
-      </p:sp>
-      <p:sp>
-        <p:nvSpPr>
-          <p:cNvPr id="3" name="TextBox 2"/>
+              <a:t>Methods (cont.)</a:t>
+            </a:r>
+          </a:p>
+        </p:txBody>
+      </p:sp>
+      <p:graphicFrame>
+        <p:nvGraphicFramePr>
+          <p:cNvPr id="3" name="Table 2"/>
+          <p:cNvGraphicFramePr>
+            <a:graphicFrameLocks noGrp="1"/>
+          </p:cNvGraphicFramePr>
+          <p:nvPr/>
+        </p:nvGraphicFramePr>
+        <p:xfrm>
+          <a:off x="914400" y="965200"/>
+          <a:ext cx="10363200" cy="914400"/>
+        </p:xfrm>
+        <a:graphic>
+          <a:graphicData uri="http://schemas.openxmlformats.org/drawingml/2006/table">
+            <a:tbl>
+              <a:tblPr firstRow="1" bandRow="1">
+                <a:tableStyleId>{5C22544A-7EE6-4342-B048-85BDC9FD1C3A}</a:tableStyleId>
+              </a:tblPr>
+              <a:tblGrid>
+                <a:gridCol w="2590800"/>
+                <a:gridCol w="2590800"/>
+                <a:gridCol w="2590800"/>
+                <a:gridCol w="2590800"/>
+              </a:tblGrid>
+              <a:tr h="304800">
+                <a:tc>
+                  <a:txBody>
+                    <a:bodyPr/>
+                    <a:lstStyle/>
+                    <a:p>
+                      <a:r>
+                        <a:rPr sz="1019" b="1">
+                          <a:solidFill>
+                            <a:srgbClr val="000000"/>
+                          </a:solidFill>
+                        </a:rPr>
+                        <a:t>Assumption</a:t>
+                      </a:r>
+                    </a:p>
+                  </a:txBody>
+                  <a:tcPr/>
+                </a:tc>
+                <a:tc>
+                  <a:txBody>
+                    <a:bodyPr/>
+                    <a:lstStyle/>
+                    <a:p>
+                      <a:r>
+                        <a:rPr sz="1019" b="1">
+                          <a:solidFill>
+                            <a:srgbClr val="000000"/>
+                          </a:solidFill>
+                        </a:rPr>
+                        <a:t>Statement</a:t>
+                      </a:r>
+                    </a:p>
+                  </a:txBody>
+                  <a:tcPr/>
+                </a:tc>
+                <a:tc>
+                  <a:txBody>
+                    <a:bodyPr/>
+                    <a:lstStyle/>
+                    <a:p>
+                      <a:r>
+                        <a:rPr sz="1019" b="1">
+                          <a:solidFill>
+                            <a:srgbClr val="000000"/>
+                          </a:solidFill>
+                        </a:rPr>
+                        <a:t>Status</a:t>
+                      </a:r>
+                    </a:p>
+                  </a:txBody>
+                  <a:tcPr/>
+                </a:tc>
+                <a:tc>
+                  <a:txBody>
+                    <a:bodyPr/>
+                    <a:lstStyle/>
+                    <a:p>
+                      <a:r>
+                        <a:rPr sz="1019" b="1">
+                          <a:solidFill>
+                            <a:srgbClr val="000000"/>
+                          </a:solidFill>
+                        </a:rPr>
+                        <a:t>Challenged by</a:t>
+                      </a:r>
+                    </a:p>
+                  </a:txBody>
+                  <a:tcPr/>
+                </a:tc>
+              </a:tr>
+              <a:tr h="304800">
+                <a:tc>
+                  <a:txBody>
+                    <a:bodyPr/>
+                    <a:lstStyle/>
+                    <a:p>
+                      <a:r>
+                        <a:rPr sz="1019" b="0">
+                          <a:solidFill>
+                            <a:srgbClr val="000000"/>
+                          </a:solidFill>
+                        </a:rPr>
+                        <a:t>dropout is ignorable given baseline</a:t>
+                      </a:r>
+                    </a:p>
+                  </a:txBody>
+                  <a:tcPr/>
+                </a:tc>
+                <a:tc>
+                  <a:txBody>
+                    <a:bodyPr/>
+                    <a:lstStyle/>
+                    <a:p>
+                      <a:r>
+                        <a:rPr sz="1019" b="0">
+                          <a:solidFill>
+                            <a:srgbClr val="000000"/>
+                          </a:solidFill>
+                        </a:rPr>
+                        <a:t>units who left the study differ from those who stayed only through what was measured before randomization</a:t>
+                      </a:r>
+                    </a:p>
+                  </a:txBody>
+                  <a:tcPr/>
+                </a:tc>
+                <a:tc>
+                  <a:txBody>
+                    <a:bodyPr/>
+                    <a:lstStyle/>
+                    <a:p>
+                      <a:r>
+                        <a:rPr sz="1019" b="0">
+                          <a:solidFill>
+                            <a:srgbClr val="000000"/>
+                          </a:solidFill>
+                        </a:rPr>
+                        <a:t>is assumed and has not been checked</a:t>
+                      </a:r>
+                    </a:p>
+                  </a:txBody>
+                  <a:tcPr/>
+                </a:tc>
+                <a:tc>
+                  <a:txBody>
+                    <a:bodyPr/>
+                    <a:lstStyle/>
+                    <a:p>
+                      <a:r>
+                        <a:rPr sz="1019" b="0">
+                          <a:solidFill>
+                            <a:srgbClr val="000000"/>
+                          </a:solidFill>
+                        </a:rPr>
+                        <a:t>a tipping-point analysis over plausible departures from ignorability</a:t>
+                      </a:r>
+                    </a:p>
+                  </a:txBody>
+                  <a:tcPr/>
+                </a:tc>
+              </a:tr>
+              <a:tr h="304800">
+                <a:tc>
+                  <a:txBody>
+                    <a:bodyPr/>
+                    <a:lstStyle/>
+                    <a:p>
+                      <a:r>
+                        <a:rPr sz="1019" b="0">
+                          <a:solidFill>
+                            <a:srgbClr val="000000"/>
+                          </a:solidFill>
+                        </a:rPr>
+                        <a:t>the pooled contrast answers the question</a:t>
+                      </a:r>
+                    </a:p>
+                  </a:txBody>
+                  <a:tcPr/>
+                </a:tc>
+                <a:tc>
+                  <a:txBody>
+                    <a:bodyPr/>
+                    <a:lstStyle/>
+                    <a:p>
+                      <a:r>
+                        <a:rPr sz="1019" b="0">
+                          <a:solidFill>
+                            <a:srgbClr val="000000"/>
+                          </a:solidFill>
+                        </a:rPr>
+                        <a:t>a single number over all age bands describes the effect the decision is about</a:t>
+                      </a:r>
+                    </a:p>
+                  </a:txBody>
+                  <a:tcPr/>
+                </a:tc>
+                <a:tc>
+                  <a:txBody>
+                    <a:bodyPr/>
+                    <a:lstStyle/>
+                    <a:p>
+                      <a:r>
+                        <a:rPr sz="1019" b="0">
+                          <a:solidFill>
+                            <a:srgbClr val="000000"/>
+                          </a:solidFill>
+                        </a:rPr>
+                        <a:t>is known to fail</a:t>
+                      </a:r>
+                    </a:p>
+                  </a:txBody>
+                  <a:tcPr/>
+                </a:tc>
+                <a:tc>
+                  <a:txBody>
+                    <a:bodyPr/>
+                    <a:lstStyle/>
+                    <a:p>
+                      <a:r>
+                        <a:rPr sz="1019" b="0">
+                          <a:solidFill>
+                            <a:srgbClr val="000000"/>
+                          </a:solidFill>
+                        </a:rPr>
+                        <a:t>heterogeneity across the pre-specified strata</a:t>
+                      </a:r>
+                    </a:p>
+                  </a:txBody>
+                  <a:tcPr/>
+                </a:tc>
+              </a:tr>
+            </a:tbl>
+          </a:graphicData>
+        </a:graphic>
+      </p:graphicFrame>
+      <p:sp>
+        <p:nvSpPr>
+          <p:cNvPr id="4" name="TextBox 3"/>
           <p:cNvSpPr txBox="1"/>
           <p:nvPr/>
         </p:nvSpPr>
         <p:spPr>
           <a:xfrm>
-            <a:off x="914400" y="965200"/>
-            <a:ext cx="10261600" cy="889000"/>
+            <a:off x="914400" y="2032000"/>
+            <a:ext cx="10363200" cy="3911600"/>
           </a:xfrm>
           <a:prstGeom prst="rect">
             <a:avLst/>
@@ -8389,32 +9306,38 @@
           <a:lstStyle/>
           <a:p>
             <a:r>
-              <a:rPr sz="1019" b="0">
+              <a:rPr sz="1019" b="1">
                 <a:solidFill>
                   <a:srgbClr val="000000"/>
                 </a:solidFill>
               </a:rPr>
-              <a:t>40 MG VS CONTROL, AGE 25-35</a:t>
-            </a:r>
-          </a:p>
-          <a:p>
-            <a:r>
-              <a:rPr sz="960" b="1">
+              <a:t>assumption  </a:t>
+            </a:r>
+            <a:r>
+              <a:rPr sz="1080" b="0">
                 <a:solidFill>
                   <a:srgbClr val="000000"/>
                 </a:solidFill>
               </a:rPr>
-              <a:t>-5.26 mmHg</a:t>
-            </a:r>
-          </a:p>
-          <a:p>
-            <a:r>
-              <a:rPr sz="1019" b="0">
+              <a:t>Adherence was not adjusted for: it lies on the path from arm to outcome, and conditioning on it would break the randomization.</a:t>
+            </a:r>
+          </a:p>
+          <a:p>
+            <a:r>
+              <a:rPr sz="1019" b="1">
                 <a:solidFill>
                   <a:srgbClr val="000000"/>
                 </a:solidFill>
               </a:rPr>
-              <a:t>[-8.166, -2.363] (90% WALD)</a:t>
+              <a:t>assumption  </a:t>
+            </a:r>
+            <a:r>
+              <a:rPr sz="1080" b="0">
+                <a:solidFill>
+                  <a:srgbClr val="000000"/>
+                </a:solidFill>
+              </a:rPr>
+              <a:t>The pooled 40 mg contrast is reported alongside the per-band contrasts, never instead of them.</a:t>
             </a:r>
           </a:p>
         </p:txBody>
@@ -8465,7 +9388,7 @@
                   <a:srgbClr val="000000"/>
                 </a:solidFill>
               </a:rPr>
-              <a:t>Model checking</a:t>
+              <a:t>Results</a:t>
             </a:r>
           </a:p>
         </p:txBody>
@@ -8498,7 +9421,7 @@
                   <a:srgbClr val="000000"/>
                 </a:solidFill>
               </a:rPr>
-              <a:t>UNITS STILL ON STUDY AT THE FINAL WEEK</a:t>
+              <a:t>40 MG VS CONTROL, POOLED</a:t>
             </a:r>
           </a:p>
           <a:p>
@@ -8508,7 +9431,17 @@
                   <a:srgbClr val="000000"/>
                 </a:solidFill>
               </a:rPr>
-              <a:t>0.797</a:t>
+              <a:t>-1.53 mmHg</a:t>
+            </a:r>
+          </a:p>
+          <a:p>
+            <a:r>
+              <a:rPr sz="1019" b="0">
+                <a:solidFill>
+                  <a:srgbClr val="000000"/>
+                </a:solidFill>
+              </a:rPr>
+              <a:t>[-3.0, -0.1] (90% WALD)</a:t>
             </a:r>
           </a:p>
         </p:txBody>
@@ -8541,7 +9474,7 @@
                   <a:srgbClr val="000000"/>
                 </a:solidFill>
               </a:rPr>
-              <a:t>UNITS CONTRIBUTING TO THE PRIMARY ENDPOINT</a:t>
+              <a:t>20 MG VS CONTROL, POOLED</a:t>
             </a:r>
           </a:p>
           <a:p>
@@ -8551,7 +9484,17 @@
                   <a:srgbClr val="000000"/>
                 </a:solidFill>
               </a:rPr>
-              <a:t>372</a:t>
+              <a:t>-4.80 mmHg</a:t>
+            </a:r>
+          </a:p>
+          <a:p>
+            <a:r>
+              <a:rPr sz="1019" b="0">
+                <a:solidFill>
+                  <a:srgbClr val="000000"/>
+                </a:solidFill>
+              </a:rPr>
+              <a:t>[-6.2, -3.4] (90% WALD)</a:t>
             </a:r>
           </a:p>
         </p:txBody>
@@ -8584,7 +9527,7 @@
                   <a:srgbClr val="000000"/>
                 </a:solidFill>
               </a:rPr>
-              <a:t>UNITS RANDOMIZED IN BAND AGE 25 35</a:t>
+              <a:t>10 MG VS CONTROL, POOLED</a:t>
             </a:r>
           </a:p>
           <a:p>
@@ -8594,7 +9537,17 @@
                   <a:srgbClr val="000000"/>
                 </a:solidFill>
               </a:rPr>
-              <a:t>100</a:t>
+              <a:t>-5.27 mmHg</a:t>
+            </a:r>
+          </a:p>
+          <a:p>
+            <a:r>
+              <a:rPr sz="1019" b="0">
+                <a:solidFill>
+                  <a:srgbClr val="000000"/>
+                </a:solidFill>
+              </a:rPr>
+              <a:t>[-6.6, -3.9] (90% WALD)</a:t>
             </a:r>
           </a:p>
         </p:txBody>
@@ -8627,7 +9580,7 @@
                   <a:srgbClr val="000000"/>
                 </a:solidFill>
               </a:rPr>
-              <a:t>UNITS RANDOMIZED IN BAND AGE 36 50</a:t>
+              <a:t>40 MG VS CONTROL, AGE 51+</a:t>
             </a:r>
           </a:p>
           <a:p>
@@ -8637,7 +9590,17 @@
                   <a:srgbClr val="000000"/>
                 </a:solidFill>
               </a:rPr>
-              <a:t>160</a:t>
+              <a:t>6.20 mmHg</a:t>
+            </a:r>
+          </a:p>
+          <a:p>
+            <a:r>
+              <a:rPr sz="1019" b="0">
+                <a:solidFill>
+                  <a:srgbClr val="000000"/>
+                </a:solidFill>
+              </a:rPr>
+              <a:t>[4.0, 8.4] (90% WALD)</a:t>
             </a:r>
           </a:p>
         </p:txBody>
@@ -8670,7 +9633,7 @@
                   <a:srgbClr val="000000"/>
                 </a:solidFill>
               </a:rPr>
-              <a:t>Model checking evaluates study completion and the fit of the estimation structure rather than estimating treatment contrasts. The diagnostic record tracks unit participation across the randomized age strata. The proportion of units still on study at the final week is 0.797. There are 372 units contributing to the primary endpoint. By age stratum, 100 units were randomized in the band aged 25 to 35, 160 units in the band aged 36 to 50, and 140 units in the band aged 51 plus. These diagnostics describe the observed data patterns rather than the effect itself. Diagnostic checks can only reduce confidence in the primary estimates when discrepancies emerge, never establish them. The model fit depends on assumptions that remain unresolved in the analysis. Specifically, the analysis relies on the unresolved assumption that dropout is ignorable given baseline. It also leaves unresolved the assumption that the pooled contrast answers the question. The diagnostic values do not settle whether these missing-data or pooling assumptions hold. They outline the completeness of the sample while leaving the underlying identification assumptions open.</a:t>
+              <a:t>The comparison of active doses against control addresses the question and decision threshold specified in the introduction under the identification strategy from the methods. For 10 mg versus control, the pooled estimate is -5.27 mmHg (90% WALD -6.63 to -3.91 mmHg). For 20 mg versus control, the pooled estimate is -4.80 mmHg (90% WALD -6.17 to -3.44 mmHg). For 40 mg versus control, the pooled estimate is -1.53 mmHg (90% WALD -2.97 to -0.10 mmHg). These estimated quantities appear alongside their intervals and thresholds in Table 2. When evaluated within age categories, the estimate for 40 mg versus control in the age 25-35 group is -5.26 mmHg (90% WALD -8.17 to -2.36 mmHg). For 40 mg versus control in the age 51+ group, the estimate is 6.20 mmHg (90% WALD 3.98 to 8.42 mmHg). These estimated quantities and their intervals are displayed in Figure 2 relative to the decision threshold.</a:t>
             </a:r>
           </a:p>
         </p:txBody>
@@ -8721,7 +9684,7 @@
                   <a:srgbClr val="000000"/>
                 </a:solidFill>
               </a:rPr>
-              <a:t>Model checking (cont.)</a:t>
+              <a:t>Results (cont.)</a:t>
             </a:r>
           </a:p>
         </p:txBody>
@@ -8754,7 +9717,7 @@
                   <a:srgbClr val="000000"/>
                 </a:solidFill>
               </a:rPr>
-              <a:t>UNITS RANDOMIZED IN BAND AGE 51 PLUS</a:t>
+              <a:t>40 MG VS CONTROL, AGE 25-35</a:t>
             </a:r>
           </a:p>
           <a:p>
@@ -8764,7 +9727,17 @@
                   <a:srgbClr val="000000"/>
                 </a:solidFill>
               </a:rPr>
-              <a:t>140</a:t>
+              <a:t>-5.26 mmHg</a:t>
+            </a:r>
+          </a:p>
+          <a:p>
+            <a:r>
+              <a:rPr sz="1019" b="0">
+                <a:solidFill>
+                  <a:srgbClr val="000000"/>
+                </a:solidFill>
+              </a:rPr>
+              <a:t>[-8.2, -2.4] (90% WALD)</a:t>
             </a:r>
           </a:p>
         </p:txBody>

</xml_diff>